<commit_message>
Make discounts fully optional and owner-configurable in Spin Wheel, Settings Modal and Pitch Deck
</commit_message>
<xml_diff>
--- a/public/menuz_executive_pitch_deck.pptx
+++ b/public/menuz_executive_pitch_deck.pptx
@@ -4017,7 +4017,7 @@
               </a:defRPr>
             </a:pPr>
             <a:r>
-              <a:t>🎉 Customizable prizes: 15% off food bill, free dessert, or mocktail upgrade.</a:t>
+              <a:t>🎉 Zero Forced Discounting: 100% margin safe by default with chef treats &amp; VIP passes.</a:t>
             </a:r>
           </a:p>
           <a:p>
@@ -4033,7 +4033,7 @@
               </a:defRPr>
             </a:pPr>
             <a:r>
-              <a:t>🎉 Creates playful dining excitement, guaranteeing high table engagement.</a:t>
+              <a:t>🎉 Optional Owner-Decided Discount: Operators can toggle discounts ON and set custom % (e.g. 5%, 10%, 15%).</a:t>
             </a:r>
           </a:p>
           <a:p>
@@ -4049,7 +4049,23 @@
               </a:defRPr>
             </a:pPr>
             <a:r>
-              <a:t>🎉 Ties reward redemption directly to final billing.</a:t>
+              <a:t>🎉 Creates playful dining excitement while keeping operators in 100% pricing control.</a:t>
+            </a:r>
+          </a:p>
+          <a:p>
+            <a:pPr>
+              <a:spcBef>
+                <a:spcPts val="1000"/>
+              </a:spcBef>
+              <a:defRPr sz="1300">
+                <a:solidFill>
+                  <a:srgbClr val="CBD5E1"/>
+                </a:solidFill>
+                <a:latin typeface="Arial"/>
+              </a:defRPr>
+            </a:pPr>
+            <a:r>
+              <a:t>🎉 Ties reward redemption directly to final billing with single-use session locks.</a:t>
             </a:r>
           </a:p>
         </p:txBody>
@@ -9947,7 +9963,7 @@
               </a:defRPr>
             </a:pPr>
             <a:r>
-              <a:t>Configurable Bundle Deals</a:t>
+              <a:t>Curated Pairing Add-Ons</a:t>
             </a:r>
           </a:p>
           <a:p>
@@ -9963,7 +9979,7 @@
               </a:defRPr>
             </a:pPr>
             <a:r>
-              <a:t>OWNER PROFIT CONTROL</a:t>
+              <a:t>HIGH MARGIN PAIRINGS</a:t>
             </a:r>
           </a:p>
           <a:p>
@@ -9979,7 +9995,7 @@
               </a:defRPr>
             </a:pPr>
             <a:r>
-              <a:t>Owners configure bundle discounts (e.g. 10-15% off when added as a pair). Diners love the value while restaurants sell more beverages and desserts.</a:t>
+              <a:t>Owners configure high-margin beverage and dessert pairings. Diners enjoy chef-recommended combinations while restaurants sell more appetizers and drinks without price slashing.</a:t>
             </a:r>
           </a:p>
         </p:txBody>

</xml_diff>

<commit_message>
Keep only slide deck presentation, add plan comparison matrix, fix restaurant persistence vault, active venue hub, and resolve site discoloration
</commit_message>
<xml_diff>
--- a/public/menuz_executive_pitch_deck.pptx
+++ b/public/menuz_executive_pitch_deck.pptx
@@ -23,6 +23,7 @@
     <p:sldId id="271" r:id="rId22"/>
     <p:sldId id="272" r:id="rId23"/>
     <p:sldId id="273" r:id="rId24"/>
+    <p:sldId id="274" r:id="rId25"/>
   </p:sldIdLst>
   <p:sldSz cx="12191695" cy="6858000" type="screen4x3"/>
   <p:notesSz cx="6858000" cy="9144000"/>
@@ -3385,7 +3386,7 @@
               </a:defRPr>
             </a:pPr>
             <a:r>
-              <a:t>⚡  Commercial Model: Flat ₹1,999/mo, 0% commission, and 100% customer WhatsApp data ownership.</a:t>
+              <a:t>⚡  Commercial Model: Single Outlet ₹5,000/mo, Enterprise ₹10,000/mo, 0% commission, and 100% data ownership.</a:t>
             </a:r>
           </a:p>
         </p:txBody>
@@ -6116,7 +6117,7 @@
               </a:defRPr>
             </a:pPr>
             <a:r>
-              <a:t>Flat ₹1,999/Month • 0% Commission • 100% Data Ownership</a:t>
+              <a:t>Single Outlet ₹5,000/Mo • Enterprise ₹10,000/Mo • 0% Commission</a:t>
             </a:r>
           </a:p>
         </p:txBody>
@@ -6152,7 +6153,7 @@
               </a:defRPr>
             </a:pPr>
             <a:r>
-              <a:t>Transparent pricing with no arbitrary trial limitations or revenue deductions.</a:t>
+              <a:t>Transparent subscription pricing with zero commission on food sales and 100% data ownership.</a:t>
             </a:r>
           </a:p>
         </p:txBody>
@@ -6166,7 +6167,184 @@
         <p:spPr>
           <a:xfrm>
             <a:off x="731520" y="1828800"/>
-            <a:ext cx="10698480" cy="4572000"/>
+            <a:ext cx="5212080" cy="4572000"/>
+          </a:xfrm>
+          <a:prstGeom prst="roundRect">
+            <a:avLst/>
+          </a:prstGeom>
+          <a:solidFill>
+            <a:srgbClr val="131C2E"/>
+          </a:solidFill>
+          <a:ln w="19050">
+            <a:solidFill>
+              <a:srgbClr val="06B6D4"/>
+            </a:solidFill>
+          </a:ln>
+        </p:spPr>
+        <p:style>
+          <a:lnRef idx="1">
+            <a:schemeClr val="accent1"/>
+          </a:lnRef>
+          <a:fillRef idx="3">
+            <a:schemeClr val="accent1"/>
+          </a:fillRef>
+          <a:effectRef idx="2">
+            <a:schemeClr val="accent1"/>
+          </a:effectRef>
+          <a:fontRef idx="minor">
+            <a:schemeClr val="lt1"/>
+          </a:fontRef>
+        </p:style>
+        <p:txBody>
+          <a:bodyPr rtlCol="0" anchor="ctr"/>
+          <a:lstStyle/>
+          <a:p>
+            <a:pPr algn="ctr"/>
+          </a:p>
+        </p:txBody>
+      </p:sp>
+      <p:sp>
+        <p:nvSpPr>
+          <p:cNvPr id="7" name="TextBox 6"/>
+          <p:cNvSpPr txBox="1"/>
+          <p:nvPr/>
+        </p:nvSpPr>
+        <p:spPr>
+          <a:xfrm>
+            <a:off x="914400" y="2011680"/>
+            <a:ext cx="4846320" cy="4206240"/>
+          </a:xfrm>
+          <a:prstGeom prst="rect">
+            <a:avLst/>
+          </a:prstGeom>
+          <a:noFill/>
+        </p:spPr>
+        <p:txBody>
+          <a:bodyPr wrap="square">
+            <a:spAutoFit/>
+          </a:bodyPr>
+          <a:lstStyle/>
+          <a:p>
+            <a:pPr>
+              <a:defRPr sz="1800" b="1">
+                <a:solidFill>
+                  <a:srgbClr val="06B6D4"/>
+                </a:solidFill>
+                <a:latin typeface="Georgia"/>
+              </a:defRPr>
+            </a:pPr>
+            <a:r>
+              <a:t>Single Outlet Plan — ₹5,000 / Month</a:t>
+            </a:r>
+          </a:p>
+          <a:p>
+            <a:pPr>
+              <a:spcBef>
+                <a:spcPts val="600"/>
+              </a:spcBef>
+              <a:defRPr sz="1150">
+                <a:solidFill>
+                  <a:srgbClr val="CBD5E1"/>
+                </a:solidFill>
+                <a:latin typeface="Arial"/>
+              </a:defRPr>
+            </a:pPr>
+            <a:r>
+              <a:t>• Full Interactive Dining OS: Multiplayer cart sync, zero app download QR menus.</a:t>
+            </a:r>
+          </a:p>
+          <a:p>
+            <a:pPr>
+              <a:spcBef>
+                <a:spcPts val="600"/>
+              </a:spcBef>
+              <a:defRPr sz="1150">
+                <a:solidFill>
+                  <a:srgbClr val="CBD5E1"/>
+                </a:solidFill>
+                <a:latin typeface="Arial"/>
+              </a:defRPr>
+            </a:pPr>
+            <a:r>
+              <a:t>• Hardware-Free KOT Routing: Direct thermal ESC/POS 80mm printing + WhatsApp alerts.</a:t>
+            </a:r>
+          </a:p>
+          <a:p>
+            <a:pPr>
+              <a:spcBef>
+                <a:spcPts val="600"/>
+              </a:spcBef>
+              <a:defRPr sz="1150">
+                <a:solidFill>
+                  <a:srgbClr val="CBD5E1"/>
+                </a:solidFill>
+                <a:latin typeface="Arial"/>
+              </a:defRPr>
+            </a:pPr>
+            <a:r>
+              <a:t>• Reputation Triad Engine: 1-Click Google review generator + 15-min floor shield recovery.</a:t>
+            </a:r>
+          </a:p>
+          <a:p>
+            <a:pPr>
+              <a:spcBef>
+                <a:spcPts val="600"/>
+              </a:spcBef>
+              <a:defRPr sz="1150">
+                <a:solidFill>
+                  <a:srgbClr val="CBD5E1"/>
+                </a:solidFill>
+                <a:latin typeface="Arial"/>
+              </a:defRPr>
+            </a:pPr>
+            <a:r>
+              <a:t>• Gamified Lucky Wheel: 100% Owner Configured prizes (Zero forced bill discounts).</a:t>
+            </a:r>
+          </a:p>
+          <a:p>
+            <a:pPr>
+              <a:spcBef>
+                <a:spcPts val="600"/>
+              </a:spcBef>
+              <a:defRPr sz="1150">
+                <a:solidFill>
+                  <a:srgbClr val="CBD5E1"/>
+                </a:solidFill>
+                <a:latin typeface="Arial"/>
+              </a:defRPr>
+            </a:pPr>
+            <a:r>
+              <a:t>• 100% Data Ownership: Full verified guest phone numbers &amp; dining histories.</a:t>
+            </a:r>
+          </a:p>
+          <a:p>
+            <a:pPr>
+              <a:spcBef>
+                <a:spcPts val="600"/>
+              </a:spcBef>
+              <a:defRPr sz="1150">
+                <a:solidFill>
+                  <a:srgbClr val="CBD5E1"/>
+                </a:solidFill>
+                <a:latin typeface="Arial"/>
+              </a:defRPr>
+            </a:pPr>
+            <a:r>
+              <a:t>• Zero Setup Fees: Month-to-month billing with no lock-in contracts.</a:t>
+            </a:r>
+          </a:p>
+        </p:txBody>
+      </p:sp>
+      <p:sp>
+        <p:nvSpPr>
+          <p:cNvPr id="8" name="Rounded Rectangle 7"/>
+          <p:cNvSpPr/>
+          <p:nvPr/>
+        </p:nvSpPr>
+        <p:spPr>
+          <a:xfrm>
+            <a:off x="6217920" y="1828800"/>
+            <a:ext cx="5212080" cy="4572000"/>
           </a:xfrm>
           <a:prstGeom prst="roundRect">
             <a:avLst/>
@@ -6204,14 +6382,14 @@
       </p:sp>
       <p:sp>
         <p:nvSpPr>
-          <p:cNvPr id="7" name="TextBox 6"/>
+          <p:cNvPr id="9" name="TextBox 8"/>
           <p:cNvSpPr txBox="1"/>
           <p:nvPr/>
         </p:nvSpPr>
         <p:spPr>
           <a:xfrm>
-            <a:off x="1005840" y="2057400"/>
-            <a:ext cx="10149840" cy="4114800"/>
+            <a:off x="6400800" y="2011680"/>
+            <a:ext cx="4846320" cy="4206240"/>
           </a:xfrm>
           <a:prstGeom prst="rect">
             <a:avLst/>
@@ -6225,7 +6403,7 @@
           <a:lstStyle/>
           <a:p>
             <a:pPr>
-              <a:defRPr sz="2000" b="1">
+              <a:defRPr sz="1800" b="1">
                 <a:solidFill>
                   <a:srgbClr val="F59E0B"/>
                 </a:solidFill>
@@ -6233,15 +6411,15 @@
               </a:defRPr>
             </a:pPr>
             <a:r>
-              <a:t>Why Restaurant Owners Choose Menuz over Delivery Aggregators</a:t>
+              <a:t>Multi-Outlet Enterprise — ₹10,000 / Month</a:t>
             </a:r>
           </a:p>
           <a:p>
             <a:pPr>
               <a:spcBef>
-                <a:spcPts val="1200"/>
+                <a:spcPts val="600"/>
               </a:spcBef>
-              <a:defRPr sz="1350">
+              <a:defRPr sz="1150">
                 <a:solidFill>
                   <a:srgbClr val="CBD5E1"/>
                 </a:solidFill>
@@ -6249,15 +6427,15 @@
               </a:defRPr>
             </a:pPr>
             <a:r>
-              <a:t>💼 Direct Access Onboarding (No Arbitrary Trial Timers): As platform owner, you grant full, unrestricted operational access directly to partner restaurants upon partnership.</a:t>
+              <a:t>• Centralized Multi-Branch HQ: Unified menu catalog sync &amp; brand-wide analytics.</a:t>
             </a:r>
           </a:p>
           <a:p>
             <a:pPr>
               <a:spcBef>
-                <a:spcPts val="1200"/>
+                <a:spcPts val="600"/>
               </a:spcBef>
-              <a:defRPr sz="1350">
+              <a:defRPr sz="1150">
                 <a:solidFill>
                   <a:srgbClr val="CBD5E1"/>
                 </a:solidFill>
@@ -6265,15 +6443,15 @@
               </a:defRPr>
             </a:pPr>
             <a:r>
-              <a:t>💼 Flat ₹1,999 / Month Flat Subscription: Zero commission on food sales. Restaurants keep 100% of their billing revenue — saving ₹30,000 to ₹80,000 monthly compared to aggregator commissions.</a:t>
+              <a:t>• Multi-Kitchen Routing: Load-balanced KOTs across separate culinary sections.</a:t>
             </a:r>
           </a:p>
           <a:p>
             <a:pPr>
               <a:spcBef>
-                <a:spcPts val="1200"/>
+                <a:spcPts val="600"/>
               </a:spcBef>
-              <a:defRPr sz="1350">
+              <a:defRPr sz="1150">
                 <a:solidFill>
                   <a:srgbClr val="CBD5E1"/>
                 </a:solidFill>
@@ -6281,15 +6459,15 @@
               </a:defRPr>
             </a:pPr>
             <a:r>
-              <a:t>💼 100% Customer WhatsApp Data Ownership: Restaurants own their verified customer phone numbers and dining histories for targeted festival and weekend remarketing campaigns.</a:t>
+              <a:t>• Custom POS Integrations: 2-Way REST API bridge for Petpooja, POSist, RanceLab.</a:t>
             </a:r>
           </a:p>
           <a:p>
             <a:pPr>
               <a:spcBef>
-                <a:spcPts val="1200"/>
+                <a:spcPts val="600"/>
               </a:spcBef>
-              <a:defRPr sz="1350">
+              <a:defRPr sz="1150">
                 <a:solidFill>
                   <a:srgbClr val="CBD5E1"/>
                 </a:solidFill>
@@ -6297,7 +6475,39 @@
               </a:defRPr>
             </a:pPr>
             <a:r>
-              <a:t>💼 High-Durability Acrylic QR Stands Included: Premium acrylic QR table stands and kitchen thermal printer configuration guides supplied on rollout.</a:t>
+              <a:t>• White-Label Branding: Custom domain, branded QR stands, and bespoke themes.</a:t>
+            </a:r>
+          </a:p>
+          <a:p>
+            <a:pPr>
+              <a:spcBef>
+                <a:spcPts val="600"/>
+              </a:spcBef>
+              <a:defRPr sz="1150">
+                <a:solidFill>
+                  <a:srgbClr val="CBD5E1"/>
+                </a:solidFill>
+                <a:latin typeface="Arial"/>
+              </a:defRPr>
+            </a:pPr>
+            <a:r>
+              <a:t>• Branch Loyalty Rules: Location-specific wheel reward quotas &amp; fraud limits.</a:t>
+            </a:r>
+          </a:p>
+          <a:p>
+            <a:pPr>
+              <a:spcBef>
+                <a:spcPts val="600"/>
+              </a:spcBef>
+              <a:defRPr sz="1150">
+                <a:solidFill>
+                  <a:srgbClr val="CBD5E1"/>
+                </a:solidFill>
+                <a:latin typeface="Arial"/>
+              </a:defRPr>
+            </a:pPr>
+            <a:r>
+              <a:t>• 24/7 Dedicated SLA: Personal account manager and on-premise staff training.</a:t>
             </a:r>
           </a:p>
         </p:txBody>
@@ -6394,7 +6604,7 @@
               </a:defRPr>
             </a:pPr>
             <a:r>
-              <a:t>// MARKET VALIDATION</a:t>
+              <a:t>// IN-DEPTH COMPARISON</a:t>
             </a:r>
           </a:p>
         </p:txBody>
@@ -6430,7 +6640,7 @@
               </a:defRPr>
             </a:pPr>
             <a:r>
-              <a:t>The 15-Restaurant Boardroom Stress Test: Unanimous Approval</a:t>
+              <a:t>What Exactly You Get in Each Plan: Side-by-Side Matrix</a:t>
             </a:r>
           </a:p>
         </p:txBody>
@@ -6466,446 +6676,778 @@
               </a:defRPr>
             </a:pPr>
             <a:r>
-              <a:t>How Menuz addresses the toughest operational objections across diverse dining formats.</a:t>
-            </a:r>
-          </a:p>
-        </p:txBody>
-      </p:sp>
-      <p:sp>
-        <p:nvSpPr>
-          <p:cNvPr id="6" name="Rounded Rectangle 5"/>
-          <p:cNvSpPr/>
-          <p:nvPr/>
-        </p:nvSpPr>
-        <p:spPr>
-          <a:xfrm>
-            <a:off x="731520" y="1828800"/>
-            <a:ext cx="3383280" cy="4572000"/>
-          </a:xfrm>
-          <a:prstGeom prst="roundRect">
-            <a:avLst/>
-          </a:prstGeom>
-          <a:solidFill>
-            <a:srgbClr val="131C2E"/>
-          </a:solidFill>
-          <a:ln w="19050">
-            <a:solidFill>
-              <a:srgbClr val="27364F"/>
-            </a:solidFill>
-          </a:ln>
-        </p:spPr>
-        <p:style>
-          <a:lnRef idx="1">
-            <a:schemeClr val="accent1"/>
-          </a:lnRef>
-          <a:fillRef idx="3">
-            <a:schemeClr val="accent1"/>
-          </a:fillRef>
-          <a:effectRef idx="2">
-            <a:schemeClr val="accent1"/>
-          </a:effectRef>
-          <a:fontRef idx="minor">
-            <a:schemeClr val="lt1"/>
-          </a:fontRef>
-        </p:style>
-        <p:txBody>
-          <a:bodyPr rtlCol="0" anchor="ctr"/>
-          <a:lstStyle/>
-          <a:p>
-            <a:pPr algn="ctr"/>
-          </a:p>
-        </p:txBody>
-      </p:sp>
-      <p:sp>
-        <p:nvSpPr>
-          <p:cNvPr id="7" name="TextBox 6"/>
-          <p:cNvSpPr txBox="1"/>
-          <p:nvPr/>
-        </p:nvSpPr>
-        <p:spPr>
-          <a:xfrm>
-            <a:off x="960120" y="2011680"/>
-            <a:ext cx="2926080" cy="4206240"/>
-          </a:xfrm>
-          <a:prstGeom prst="rect">
-            <a:avLst/>
-          </a:prstGeom>
-          <a:noFill/>
-        </p:spPr>
-        <p:txBody>
-          <a:bodyPr wrap="square">
-            <a:spAutoFit/>
-          </a:bodyPr>
-          <a:lstStyle/>
-          <a:p>
-            <a:pPr>
-              <a:defRPr sz="1700" b="1">
-                <a:solidFill>
-                  <a:srgbClr val="06B6D4"/>
-                </a:solidFill>
-                <a:latin typeface="Georgia"/>
-              </a:defRPr>
-            </a:pPr>
-            <a:r>
-              <a:t>Cafes &amp; High-Turnover</a:t>
-            </a:r>
-          </a:p>
-          <a:p>
-            <a:pPr>
-              <a:spcBef>
-                <a:spcPts val="200"/>
-              </a:spcBef>
-              <a:defRPr sz="1050" b="1">
-                <a:solidFill>
-                  <a:srgbClr val="94A3B8"/>
-                </a:solidFill>
-                <a:latin typeface="Arial"/>
-              </a:defRPr>
-            </a:pPr>
-            <a:r>
-              <a:t>German Bakery, Le Plaisir, Vaishali</a:t>
-            </a:r>
-          </a:p>
-          <a:p>
-            <a:pPr>
-              <a:spcBef>
-                <a:spcPts val="1000"/>
-              </a:spcBef>
-              <a:defRPr sz="1250">
-                <a:solidFill>
-                  <a:srgbClr val="CBD5E1"/>
-                </a:solidFill>
-                <a:latin typeface="Arial"/>
-              </a:defRPr>
-            </a:pPr>
-            <a:r>
-              <a:t>• Objection: 'We serve 200+ tables/day, tech must be instant.'</a:t>
-            </a:r>
-          </a:p>
-          <a:p>
-            <a:pPr>
-              <a:spcBef>
-                <a:spcPts val="1000"/>
-              </a:spcBef>
-              <a:defRPr sz="1250">
-                <a:solidFill>
-                  <a:srgbClr val="CBD5E1"/>
-                </a:solidFill>
-                <a:latin typeface="Arial"/>
-              </a:defRPr>
-            </a:pPr>
-            <a:r>
-              <a:t>• Solution: Zero app downloads. Mode A fires direct 80mm KOT in 1s.</a:t>
-            </a:r>
-          </a:p>
-          <a:p>
-            <a:pPr>
-              <a:spcBef>
-                <a:spcPts val="1000"/>
-              </a:spcBef>
-              <a:defRPr sz="1250">
-                <a:solidFill>
-                  <a:srgbClr val="CBD5E1"/>
-                </a:solidFill>
-                <a:latin typeface="Arial"/>
-              </a:defRPr>
-            </a:pPr>
-            <a:r>
-              <a:t>• Outcome: Table turnover accelerated by 14 minutes per group.</a:t>
-            </a:r>
-          </a:p>
-        </p:txBody>
-      </p:sp>
-      <p:sp>
-        <p:nvSpPr>
-          <p:cNvPr id="8" name="Rounded Rectangle 7"/>
-          <p:cNvSpPr/>
-          <p:nvPr/>
-        </p:nvSpPr>
-        <p:spPr>
-          <a:xfrm>
-            <a:off x="4389120" y="1828800"/>
-            <a:ext cx="3383280" cy="4572000"/>
-          </a:xfrm>
-          <a:prstGeom prst="roundRect">
-            <a:avLst/>
-          </a:prstGeom>
-          <a:solidFill>
-            <a:srgbClr val="131C2E"/>
-          </a:solidFill>
-          <a:ln w="19050">
-            <a:solidFill>
-              <a:srgbClr val="27364F"/>
-            </a:solidFill>
-          </a:ln>
-        </p:spPr>
-        <p:style>
-          <a:lnRef idx="1">
-            <a:schemeClr val="accent1"/>
-          </a:lnRef>
-          <a:fillRef idx="3">
-            <a:schemeClr val="accent1"/>
-          </a:fillRef>
-          <a:effectRef idx="2">
-            <a:schemeClr val="accent1"/>
-          </a:effectRef>
-          <a:fontRef idx="minor">
-            <a:schemeClr val="lt1"/>
-          </a:fontRef>
-        </p:style>
-        <p:txBody>
-          <a:bodyPr rtlCol="0" anchor="ctr"/>
-          <a:lstStyle/>
-          <a:p>
-            <a:pPr algn="ctr"/>
-          </a:p>
-        </p:txBody>
-      </p:sp>
-      <p:sp>
-        <p:nvSpPr>
-          <p:cNvPr id="9" name="TextBox 8"/>
-          <p:cNvSpPr txBox="1"/>
-          <p:nvPr/>
-        </p:nvSpPr>
-        <p:spPr>
-          <a:xfrm>
-            <a:off x="4617720" y="2011680"/>
-            <a:ext cx="2926080" cy="4206240"/>
-          </a:xfrm>
-          <a:prstGeom prst="rect">
-            <a:avLst/>
-          </a:prstGeom>
-          <a:noFill/>
-        </p:spPr>
-        <p:txBody>
-          <a:bodyPr wrap="square">
-            <a:spAutoFit/>
-          </a:bodyPr>
-          <a:lstStyle/>
-          <a:p>
-            <a:pPr>
-              <a:defRPr sz="1700" b="1">
-                <a:solidFill>
-                  <a:srgbClr val="F59E0B"/>
-                </a:solidFill>
-                <a:latin typeface="Georgia"/>
-              </a:defRPr>
-            </a:pPr>
-            <a:r>
-              <a:t>Fine Dining &amp; Bistros</a:t>
-            </a:r>
-          </a:p>
-          <a:p>
-            <a:pPr>
-              <a:spcBef>
-                <a:spcPts val="200"/>
-              </a:spcBef>
-              <a:defRPr sz="1050" b="1">
-                <a:solidFill>
-                  <a:srgbClr val="94A3B8"/>
-                </a:solidFill>
-                <a:latin typeface="Arial"/>
-              </a:defRPr>
-            </a:pPr>
-            <a:r>
-              <a:t>Arthur's Theme, Malaka Spice, Terttulia</a:t>
-            </a:r>
-          </a:p>
-          <a:p>
-            <a:pPr>
-              <a:spcBef>
-                <a:spcPts val="1000"/>
-              </a:spcBef>
-              <a:defRPr sz="1250">
-                <a:solidFill>
-                  <a:srgbClr val="CBD5E1"/>
-                </a:solidFill>
-                <a:latin typeface="Arial"/>
-              </a:defRPr>
-            </a:pPr>
-            <a:r>
-              <a:t>• Objection: 'We cannot lose human captain hospitality.'</a:t>
-            </a:r>
-          </a:p>
-          <a:p>
-            <a:pPr>
-              <a:spcBef>
-                <a:spcPts val="1000"/>
-              </a:spcBef>
-              <a:defRPr sz="1250">
-                <a:solidFill>
-                  <a:srgbClr val="CBD5E1"/>
-                </a:solidFill>
-                <a:latin typeface="Arial"/>
-              </a:defRPr>
-            </a:pPr>
-            <a:r>
-              <a:t>• Solution: Mode B allows captain to review and pace courses.</a:t>
-            </a:r>
-          </a:p>
-          <a:p>
-            <a:pPr>
-              <a:spcBef>
-                <a:spcPts val="1000"/>
-              </a:spcBef>
-              <a:defRPr sz="1250">
-                <a:solidFill>
-                  <a:srgbClr val="CBD5E1"/>
-                </a:solidFill>
-                <a:latin typeface="Arial"/>
-              </a:defRPr>
-            </a:pPr>
-            <a:r>
-              <a:t>• Outcome: Chef AI wine pairings increase beverage check size by +24%.</a:t>
-            </a:r>
-          </a:p>
-        </p:txBody>
-      </p:sp>
-      <p:sp>
-        <p:nvSpPr>
-          <p:cNvPr id="10" name="Rounded Rectangle 9"/>
-          <p:cNvSpPr/>
-          <p:nvPr/>
-        </p:nvSpPr>
-        <p:spPr>
-          <a:xfrm>
-            <a:off x="8046720" y="1828800"/>
-            <a:ext cx="3383280" cy="4572000"/>
-          </a:xfrm>
-          <a:prstGeom prst="roundRect">
-            <a:avLst/>
-          </a:prstGeom>
-          <a:solidFill>
-            <a:srgbClr val="131C2E"/>
-          </a:solidFill>
-          <a:ln w="19050">
-            <a:solidFill>
-              <a:srgbClr val="27364F"/>
-            </a:solidFill>
-          </a:ln>
-        </p:spPr>
-        <p:style>
-          <a:lnRef idx="1">
-            <a:schemeClr val="accent1"/>
-          </a:lnRef>
-          <a:fillRef idx="3">
-            <a:schemeClr val="accent1"/>
-          </a:fillRef>
-          <a:effectRef idx="2">
-            <a:schemeClr val="accent1"/>
-          </a:effectRef>
-          <a:fontRef idx="minor">
-            <a:schemeClr val="lt1"/>
-          </a:fontRef>
-        </p:style>
-        <p:txBody>
-          <a:bodyPr rtlCol="0" anchor="ctr"/>
-          <a:lstStyle/>
-          <a:p>
-            <a:pPr algn="ctr"/>
-          </a:p>
-        </p:txBody>
-      </p:sp>
-      <p:sp>
-        <p:nvSpPr>
-          <p:cNvPr id="11" name="TextBox 10"/>
-          <p:cNvSpPr txBox="1"/>
-          <p:nvPr/>
-        </p:nvSpPr>
-        <p:spPr>
-          <a:xfrm>
-            <a:off x="8275320" y="2011680"/>
-            <a:ext cx="2926080" cy="4206240"/>
-          </a:xfrm>
-          <a:prstGeom prst="rect">
-            <a:avLst/>
-          </a:prstGeom>
-          <a:noFill/>
-        </p:spPr>
-        <p:txBody>
-          <a:bodyPr wrap="square">
-            <a:spAutoFit/>
-          </a:bodyPr>
-          <a:lstStyle/>
-          <a:p>
-            <a:pPr>
-              <a:defRPr sz="1700" b="1">
-                <a:solidFill>
-                  <a:srgbClr val="F43F5E"/>
-                </a:solidFill>
-                <a:latin typeface="Georgia"/>
-              </a:defRPr>
-            </a:pPr>
-            <a:r>
-              <a:t>Breweries &amp; Restobars</a:t>
-            </a:r>
-          </a:p>
-          <a:p>
-            <a:pPr>
-              <a:spcBef>
-                <a:spcPts val="200"/>
-              </a:spcBef>
-              <a:defRPr sz="1050" b="1">
-                <a:solidFill>
-                  <a:srgbClr val="94A3B8"/>
-                </a:solidFill>
-                <a:latin typeface="Arial"/>
-              </a:defRPr>
-            </a:pPr>
-            <a:r>
-              <a:t>Effingut, FC Road Social, Agent Jack's</a:t>
-            </a:r>
-          </a:p>
-          <a:p>
-            <a:pPr>
-              <a:spcBef>
-                <a:spcPts val="1000"/>
-              </a:spcBef>
-              <a:defRPr sz="1250">
-                <a:solidFill>
-                  <a:srgbClr val="CBD5E1"/>
-                </a:solidFill>
-                <a:latin typeface="Arial"/>
-              </a:defRPr>
-            </a:pPr>
-            <a:r>
-              <a:t>• Objection: 'Large noisy groups cause chaotic ordering.'</a:t>
-            </a:r>
-          </a:p>
-          <a:p>
-            <a:pPr>
-              <a:spcBef>
-                <a:spcPts val="1000"/>
-              </a:spcBef>
-              <a:defRPr sz="1250">
-                <a:solidFill>
-                  <a:srgbClr val="CBD5E1"/>
-                </a:solidFill>
-                <a:latin typeface="Arial"/>
-              </a:defRPr>
-            </a:pPr>
-            <a:r>
-              <a:t>• Solution: Multiplayer table sync aggregates all orders with guest tags.</a:t>
-            </a:r>
-          </a:p>
-          <a:p>
-            <a:pPr>
-              <a:spcBef>
-                <a:spcPts val="1000"/>
-              </a:spcBef>
-              <a:defRPr sz="1250">
-                <a:solidFill>
-                  <a:srgbClr val="CBD5E1"/>
-                </a:solidFill>
-                <a:latin typeface="Arial"/>
-              </a:defRPr>
-            </a:pPr>
-            <a:r>
-              <a:t>• Outcome: 9:16 Instagram Story engine drives massive weekend viral reach.</a:t>
-            </a:r>
-          </a:p>
-        </p:txBody>
-      </p:sp>
+              <a:t>Transparent capability breakdown between Single Outlet (₹5,000/mo) and Enterprise (₹10,000/mo).</a:t>
+            </a:r>
+          </a:p>
+        </p:txBody>
+      </p:sp>
+      <p:graphicFrame>
+        <p:nvGraphicFramePr>
+          <p:cNvPr id="6" name="Table 5"/>
+          <p:cNvGraphicFramePr>
+            <a:graphicFrameLocks noGrp="1"/>
+          </p:cNvGraphicFramePr>
+          <p:nvPr/>
+        </p:nvGraphicFramePr>
+        <p:xfrm>
+          <a:off x="731520" y="1828800"/>
+          <a:ext cx="10698480" cy="4572000"/>
+        </p:xfrm>
+        <a:graphic>
+          <a:graphicData uri="http://schemas.openxmlformats.org/drawingml/2006/table">
+            <a:tbl>
+              <a:tblPr firstRow="1" bandRow="1">
+                <a:tableStyleId>{5C22544A-7EE6-4342-B048-85BDC9FD1C3A}</a:tableStyleId>
+              </a:tblPr>
+              <a:tblGrid>
+                <a:gridCol w="4297680"/>
+                <a:gridCol w="3200400"/>
+                <a:gridCol w="3200400"/>
+              </a:tblGrid>
+              <a:tr h="457200">
+                <a:tc>
+                  <a:txBody>
+                    <a:bodyPr/>
+                    <a:lstStyle/>
+                    <a:p>
+                      <a:pPr>
+                        <a:defRPr sz="1200" b="1">
+                          <a:solidFill>
+                            <a:srgbClr val="F59E0B"/>
+                          </a:solidFill>
+                          <a:latin typeface="Georgia"/>
+                        </a:defRPr>
+                      </a:pPr>
+                      <a:r>
+                        <a:t>Capability / Module</a:t>
+                      </a:r>
+                    </a:p>
+                  </a:txBody>
+                  <a:tcPr>
+                    <a:solidFill>
+                      <a:srgbClr val="1A2436"/>
+                    </a:solidFill>
+                  </a:tcPr>
+                </a:tc>
+                <a:tc>
+                  <a:txBody>
+                    <a:bodyPr/>
+                    <a:lstStyle/>
+                    <a:p>
+                      <a:pPr>
+                        <a:defRPr sz="1200" b="1">
+                          <a:solidFill>
+                            <a:srgbClr val="06B6D4"/>
+                          </a:solidFill>
+                          <a:latin typeface="Georgia"/>
+                        </a:defRPr>
+                      </a:pPr>
+                      <a:r>
+                        <a:t>Single Outlet (₹5,000/mo)</a:t>
+                      </a:r>
+                    </a:p>
+                  </a:txBody>
+                  <a:tcPr>
+                    <a:solidFill>
+                      <a:srgbClr val="1A2436"/>
+                    </a:solidFill>
+                  </a:tcPr>
+                </a:tc>
+                <a:tc>
+                  <a:txBody>
+                    <a:bodyPr/>
+                    <a:lstStyle/>
+                    <a:p>
+                      <a:pPr>
+                        <a:defRPr sz="1200" b="1">
+                          <a:solidFill>
+                            <a:srgbClr val="F59E0B"/>
+                          </a:solidFill>
+                          <a:latin typeface="Georgia"/>
+                        </a:defRPr>
+                      </a:pPr>
+                      <a:r>
+                        <a:t>Multi-Outlet Enterprise (₹10,000/mo)</a:t>
+                      </a:r>
+                    </a:p>
+                  </a:txBody>
+                  <a:tcPr>
+                    <a:solidFill>
+                      <a:srgbClr val="1A2436"/>
+                    </a:solidFill>
+                  </a:tcPr>
+                </a:tc>
+              </a:tr>
+              <a:tr h="457200">
+                <a:tc>
+                  <a:txBody>
+                    <a:bodyPr/>
+                    <a:lstStyle/>
+                    <a:p>
+                      <a:pPr>
+                        <a:defRPr sz="1050" b="1">
+                          <a:solidFill>
+                            <a:srgbClr val="FAFAFA"/>
+                          </a:solidFill>
+                          <a:latin typeface="Arial"/>
+                        </a:defRPr>
+                      </a:pPr>
+                      <a:r>
+                        <a:t>Venue &amp; Table Scale</a:t>
+                      </a:r>
+                    </a:p>
+                  </a:txBody>
+                  <a:tcPr>
+                    <a:solidFill>
+                      <a:srgbClr val="131C2E"/>
+                    </a:solidFill>
+                  </a:tcPr>
+                </a:tc>
+                <a:tc>
+                  <a:txBody>
+                    <a:bodyPr/>
+                    <a:lstStyle/>
+                    <a:p>
+                      <a:pPr>
+                        <a:defRPr sz="1050">
+                          <a:solidFill>
+                            <a:srgbClr val="06B6D4"/>
+                          </a:solidFill>
+                          <a:latin typeface="Arial"/>
+                        </a:defRPr>
+                      </a:pPr>
+                      <a:r>
+                        <a:t>1 Location (Unlimited Tables)</a:t>
+                      </a:r>
+                    </a:p>
+                  </a:txBody>
+                  <a:tcPr>
+                    <a:solidFill>
+                      <a:srgbClr val="131C2E"/>
+                    </a:solidFill>
+                  </a:tcPr>
+                </a:tc>
+                <a:tc>
+                  <a:txBody>
+                    <a:bodyPr/>
+                    <a:lstStyle/>
+                    <a:p>
+                      <a:pPr>
+                        <a:defRPr sz="1050">
+                          <a:solidFill>
+                            <a:srgbClr val="F59E0B"/>
+                          </a:solidFill>
+                          <a:latin typeface="Arial"/>
+                        </a:defRPr>
+                      </a:pPr>
+                      <a:r>
+                        <a:t>Multi-Outlet (Unlimited Venues &amp; Tables)</a:t>
+                      </a:r>
+                    </a:p>
+                  </a:txBody>
+                  <a:tcPr>
+                    <a:solidFill>
+                      <a:srgbClr val="131C2E"/>
+                    </a:solidFill>
+                  </a:tcPr>
+                </a:tc>
+              </a:tr>
+              <a:tr h="457200">
+                <a:tc>
+                  <a:txBody>
+                    <a:bodyPr/>
+                    <a:lstStyle/>
+                    <a:p>
+                      <a:pPr>
+                        <a:defRPr sz="1050" b="1">
+                          <a:solidFill>
+                            <a:srgbClr val="FAFAFA"/>
+                          </a:solidFill>
+                          <a:latin typeface="Arial"/>
+                        </a:defRPr>
+                      </a:pPr>
+                      <a:r>
+                        <a:t>Interactive Dining &amp; Multiplayer Cart</a:t>
+                      </a:r>
+                    </a:p>
+                  </a:txBody>
+                  <a:tcPr>
+                    <a:solidFill>
+                      <a:srgbClr val="0E1422"/>
+                    </a:solidFill>
+                  </a:tcPr>
+                </a:tc>
+                <a:tc>
+                  <a:txBody>
+                    <a:bodyPr/>
+                    <a:lstStyle/>
+                    <a:p>
+                      <a:pPr>
+                        <a:defRPr sz="1050" b="1">
+                          <a:solidFill>
+                            <a:srgbClr val="10B981"/>
+                          </a:solidFill>
+                          <a:latin typeface="Arial"/>
+                        </a:defRPr>
+                      </a:pPr>
+                      <a:r>
+                        <a:t>✓ Full Access (Zero App Download)</a:t>
+                      </a:r>
+                    </a:p>
+                  </a:txBody>
+                  <a:tcPr>
+                    <a:solidFill>
+                      <a:srgbClr val="0E1422"/>
+                    </a:solidFill>
+                  </a:tcPr>
+                </a:tc>
+                <a:tc>
+                  <a:txBody>
+                    <a:bodyPr/>
+                    <a:lstStyle/>
+                    <a:p>
+                      <a:pPr>
+                        <a:defRPr sz="1050" b="1">
+                          <a:solidFill>
+                            <a:srgbClr val="10B981"/>
+                          </a:solidFill>
+                          <a:latin typeface="Arial"/>
+                        </a:defRPr>
+                      </a:pPr>
+                      <a:r>
+                        <a:t>✓ Full Access (Zero App Download)</a:t>
+                      </a:r>
+                    </a:p>
+                  </a:txBody>
+                  <a:tcPr>
+                    <a:solidFill>
+                      <a:srgbClr val="0E1422"/>
+                    </a:solidFill>
+                  </a:tcPr>
+                </a:tc>
+              </a:tr>
+              <a:tr h="457200">
+                <a:tc>
+                  <a:txBody>
+                    <a:bodyPr/>
+                    <a:lstStyle/>
+                    <a:p>
+                      <a:pPr>
+                        <a:defRPr sz="1050" b="1">
+                          <a:solidFill>
+                            <a:srgbClr val="FAFAFA"/>
+                          </a:solidFill>
+                          <a:latin typeface="Arial"/>
+                        </a:defRPr>
+                      </a:pPr>
+                      <a:r>
+                        <a:t>Multilingual AI Menu Engine</a:t>
+                      </a:r>
+                    </a:p>
+                  </a:txBody>
+                  <a:tcPr>
+                    <a:solidFill>
+                      <a:srgbClr val="131C2E"/>
+                    </a:solidFill>
+                  </a:tcPr>
+                </a:tc>
+                <a:tc>
+                  <a:txBody>
+                    <a:bodyPr/>
+                    <a:lstStyle/>
+                    <a:p>
+                      <a:pPr>
+                        <a:defRPr sz="1050" b="1">
+                          <a:solidFill>
+                            <a:srgbClr val="10B981"/>
+                          </a:solidFill>
+                          <a:latin typeface="Arial"/>
+                        </a:defRPr>
+                      </a:pPr>
+                      <a:r>
+                        <a:t>✓ English, Hindi &amp; Marathi + Dietary</a:t>
+                      </a:r>
+                    </a:p>
+                  </a:txBody>
+                  <a:tcPr>
+                    <a:solidFill>
+                      <a:srgbClr val="131C2E"/>
+                    </a:solidFill>
+                  </a:tcPr>
+                </a:tc>
+                <a:tc>
+                  <a:txBody>
+                    <a:bodyPr/>
+                    <a:lstStyle/>
+                    <a:p>
+                      <a:pPr>
+                        <a:defRPr sz="1050" b="1">
+                          <a:solidFill>
+                            <a:srgbClr val="10B981"/>
+                          </a:solidFill>
+                          <a:latin typeface="Arial"/>
+                        </a:defRPr>
+                      </a:pPr>
+                      <a:r>
+                        <a:t>✓ English, Hindi &amp; Marathi + Dietary</a:t>
+                      </a:r>
+                    </a:p>
+                  </a:txBody>
+                  <a:tcPr>
+                    <a:solidFill>
+                      <a:srgbClr val="131C2E"/>
+                    </a:solidFill>
+                  </a:tcPr>
+                </a:tc>
+              </a:tr>
+              <a:tr h="457200">
+                <a:tc>
+                  <a:txBody>
+                    <a:bodyPr/>
+                    <a:lstStyle/>
+                    <a:p>
+                      <a:pPr>
+                        <a:defRPr sz="1050" b="1">
+                          <a:solidFill>
+                            <a:srgbClr val="FAFAFA"/>
+                          </a:solidFill>
+                          <a:latin typeface="Arial"/>
+                        </a:defRPr>
+                      </a:pPr>
+                      <a:r>
+                        <a:t>Kitchen KOT Thermal Printing</a:t>
+                      </a:r>
+                    </a:p>
+                  </a:txBody>
+                  <a:tcPr>
+                    <a:solidFill>
+                      <a:srgbClr val="0E1422"/>
+                    </a:solidFill>
+                  </a:tcPr>
+                </a:tc>
+                <a:tc>
+                  <a:txBody>
+                    <a:bodyPr/>
+                    <a:lstStyle/>
+                    <a:p>
+                      <a:pPr>
+                        <a:defRPr sz="1050" b="1">
+                          <a:solidFill>
+                            <a:srgbClr val="10B981"/>
+                          </a:solidFill>
+                          <a:latin typeface="Arial"/>
+                        </a:defRPr>
+                      </a:pPr>
+                      <a:r>
+                        <a:t>✓ Single Kitchen Station ESC/POS</a:t>
+                      </a:r>
+                    </a:p>
+                  </a:txBody>
+                  <a:tcPr>
+                    <a:solidFill>
+                      <a:srgbClr val="0E1422"/>
+                    </a:solidFill>
+                  </a:tcPr>
+                </a:tc>
+                <a:tc>
+                  <a:txBody>
+                    <a:bodyPr/>
+                    <a:lstStyle/>
+                    <a:p>
+                      <a:pPr>
+                        <a:defRPr sz="1050" b="1">
+                          <a:solidFill>
+                            <a:srgbClr val="10B981"/>
+                          </a:solidFill>
+                          <a:latin typeface="Arial"/>
+                        </a:defRPr>
+                      </a:pPr>
+                      <a:r>
+                        <a:t>✓ Multi-Kitchen &amp; Bar Routing</a:t>
+                      </a:r>
+                    </a:p>
+                  </a:txBody>
+                  <a:tcPr>
+                    <a:solidFill>
+                      <a:srgbClr val="0E1422"/>
+                    </a:solidFill>
+                  </a:tcPr>
+                </a:tc>
+              </a:tr>
+              <a:tr h="457200">
+                <a:tc>
+                  <a:txBody>
+                    <a:bodyPr/>
+                    <a:lstStyle/>
+                    <a:p>
+                      <a:pPr>
+                        <a:defRPr sz="1050" b="1">
+                          <a:solidFill>
+                            <a:srgbClr val="FAFAFA"/>
+                          </a:solidFill>
+                          <a:latin typeface="Arial"/>
+                        </a:defRPr>
+                      </a:pPr>
+                      <a:r>
+                        <a:t>POS Integrations</a:t>
+                      </a:r>
+                    </a:p>
+                  </a:txBody>
+                  <a:tcPr>
+                    <a:solidFill>
+                      <a:srgbClr val="131C2E"/>
+                    </a:solidFill>
+                  </a:tcPr>
+                </a:tc>
+                <a:tc>
+                  <a:txBody>
+                    <a:bodyPr/>
+                    <a:lstStyle/>
+                    <a:p>
+                      <a:pPr>
+                        <a:defRPr sz="1050">
+                          <a:solidFill>
+                            <a:srgbClr val="06B6D4"/>
+                          </a:solidFill>
+                          <a:latin typeface="Arial"/>
+                        </a:defRPr>
+                      </a:pPr>
+                      <a:r>
+                        <a:t>Standard POS Bridge</a:t>
+                      </a:r>
+                    </a:p>
+                  </a:txBody>
+                  <a:tcPr>
+                    <a:solidFill>
+                      <a:srgbClr val="131C2E"/>
+                    </a:solidFill>
+                  </a:tcPr>
+                </a:tc>
+                <a:tc>
+                  <a:txBody>
+                    <a:bodyPr/>
+                    <a:lstStyle/>
+                    <a:p>
+                      <a:pPr>
+                        <a:defRPr sz="1050">
+                          <a:solidFill>
+                            <a:srgbClr val="F59E0B"/>
+                          </a:solidFill>
+                          <a:latin typeface="Arial"/>
+                        </a:defRPr>
+                      </a:pPr>
+                      <a:r>
+                        <a:t>Enterprise 2-Way REST API Sync</a:t>
+                      </a:r>
+                    </a:p>
+                  </a:txBody>
+                  <a:tcPr>
+                    <a:solidFill>
+                      <a:srgbClr val="131C2E"/>
+                    </a:solidFill>
+                  </a:tcPr>
+                </a:tc>
+              </a:tr>
+              <a:tr h="457200">
+                <a:tc>
+                  <a:txBody>
+                    <a:bodyPr/>
+                    <a:lstStyle/>
+                    <a:p>
+                      <a:pPr>
+                        <a:defRPr sz="1050" b="1">
+                          <a:solidFill>
+                            <a:srgbClr val="FAFAFA"/>
+                          </a:solidFill>
+                          <a:latin typeface="Arial"/>
+                        </a:defRPr>
+                      </a:pPr>
+                      <a:r>
+                        <a:t>Google Maps SEO &amp; AI Review Builder</a:t>
+                      </a:r>
+                    </a:p>
+                  </a:txBody>
+                  <a:tcPr>
+                    <a:solidFill>
+                      <a:srgbClr val="0E1422"/>
+                    </a:solidFill>
+                  </a:tcPr>
+                </a:tc>
+                <a:tc>
+                  <a:txBody>
+                    <a:bodyPr/>
+                    <a:lstStyle/>
+                    <a:p>
+                      <a:pPr>
+                        <a:defRPr sz="1050" b="1">
+                          <a:solidFill>
+                            <a:srgbClr val="10B981"/>
+                          </a:solidFill>
+                          <a:latin typeface="Arial"/>
+                        </a:defRPr>
+                      </a:pPr>
+                      <a:r>
+                        <a:t>✓ Included (1-Click Tags)</a:t>
+                      </a:r>
+                    </a:p>
+                  </a:txBody>
+                  <a:tcPr>
+                    <a:solidFill>
+                      <a:srgbClr val="0E1422"/>
+                    </a:solidFill>
+                  </a:tcPr>
+                </a:tc>
+                <a:tc>
+                  <a:txBody>
+                    <a:bodyPr/>
+                    <a:lstStyle/>
+                    <a:p>
+                      <a:pPr>
+                        <a:defRPr sz="1050" b="1">
+                          <a:solidFill>
+                            <a:srgbClr val="10B981"/>
+                          </a:solidFill>
+                          <a:latin typeface="Arial"/>
+                        </a:defRPr>
+                      </a:pPr>
+                      <a:r>
+                        <a:t>✓ Included (1-Click Tags)</a:t>
+                      </a:r>
+                    </a:p>
+                  </a:txBody>
+                  <a:tcPr>
+                    <a:solidFill>
+                      <a:srgbClr val="0E1422"/>
+                    </a:solidFill>
+                  </a:tcPr>
+                </a:tc>
+              </a:tr>
+              <a:tr h="457200">
+                <a:tc>
+                  <a:txBody>
+                    <a:bodyPr/>
+                    <a:lstStyle/>
+                    <a:p>
+                      <a:pPr>
+                        <a:defRPr sz="1050" b="1">
+                          <a:solidFill>
+                            <a:srgbClr val="FAFAFA"/>
+                          </a:solidFill>
+                          <a:latin typeface="Arial"/>
+                        </a:defRPr>
+                      </a:pPr>
+                      <a:r>
+                        <a:t>Gamified Wheel &amp; Retention</a:t>
+                      </a:r>
+                    </a:p>
+                  </a:txBody>
+                  <a:tcPr>
+                    <a:solidFill>
+                      <a:srgbClr val="131C2E"/>
+                    </a:solidFill>
+                  </a:tcPr>
+                </a:tc>
+                <a:tc>
+                  <a:txBody>
+                    <a:bodyPr/>
+                    <a:lstStyle/>
+                    <a:p>
+                      <a:pPr>
+                        <a:defRPr sz="1050" b="1">
+                          <a:solidFill>
+                            <a:srgbClr val="10B981"/>
+                          </a:solidFill>
+                          <a:latin typeface="Arial"/>
+                        </a:defRPr>
+                      </a:pPr>
+                      <a:r>
+                        <a:t>✓ Full Owner Control (Zero Discounts)</a:t>
+                      </a:r>
+                    </a:p>
+                  </a:txBody>
+                  <a:tcPr>
+                    <a:solidFill>
+                      <a:srgbClr val="131C2E"/>
+                    </a:solidFill>
+                  </a:tcPr>
+                </a:tc>
+                <a:tc>
+                  <a:txBody>
+                    <a:bodyPr/>
+                    <a:lstStyle/>
+                    <a:p>
+                      <a:pPr>
+                        <a:defRPr sz="1050" b="1">
+                          <a:solidFill>
+                            <a:srgbClr val="10B981"/>
+                          </a:solidFill>
+                          <a:latin typeface="Arial"/>
+                        </a:defRPr>
+                      </a:pPr>
+                      <a:r>
+                        <a:t>✓ Full Control + Branch Rules</a:t>
+                      </a:r>
+                    </a:p>
+                  </a:txBody>
+                  <a:tcPr>
+                    <a:solidFill>
+                      <a:srgbClr val="131C2E"/>
+                    </a:solidFill>
+                  </a:tcPr>
+                </a:tc>
+              </a:tr>
+              <a:tr h="457200">
+                <a:tc>
+                  <a:txBody>
+                    <a:bodyPr/>
+                    <a:lstStyle/>
+                    <a:p>
+                      <a:pPr>
+                        <a:defRPr sz="1050" b="1">
+                          <a:solidFill>
+                            <a:srgbClr val="FAFAFA"/>
+                          </a:solidFill>
+                          <a:latin typeface="Arial"/>
+                        </a:defRPr>
+                      </a:pPr>
+                      <a:r>
+                        <a:t>Multi-Branch Centralized HQ</a:t>
+                      </a:r>
+                    </a:p>
+                  </a:txBody>
+                  <a:tcPr>
+                    <a:solidFill>
+                      <a:srgbClr val="0E1422"/>
+                    </a:solidFill>
+                  </a:tcPr>
+                </a:tc>
+                <a:tc>
+                  <a:txBody>
+                    <a:bodyPr/>
+                    <a:lstStyle/>
+                    <a:p>
+                      <a:pPr>
+                        <a:defRPr sz="1050">
+                          <a:solidFill>
+                            <a:srgbClr val="06B6D4"/>
+                          </a:solidFill>
+                          <a:latin typeface="Arial"/>
+                        </a:defRPr>
+                      </a:pPr>
+                      <a:r>
+                        <a:t>— (Single venue analytics)</a:t>
+                      </a:r>
+                    </a:p>
+                  </a:txBody>
+                  <a:tcPr>
+                    <a:solidFill>
+                      <a:srgbClr val="0E1422"/>
+                    </a:solidFill>
+                  </a:tcPr>
+                </a:tc>
+                <a:tc>
+                  <a:txBody>
+                    <a:bodyPr/>
+                    <a:lstStyle/>
+                    <a:p>
+                      <a:pPr>
+                        <a:defRPr sz="1050" b="1">
+                          <a:solidFill>
+                            <a:srgbClr val="10B981"/>
+                          </a:solidFill>
+                          <a:latin typeface="Arial"/>
+                        </a:defRPr>
+                      </a:pPr>
+                      <a:r>
+                        <a:t>✓ Centralized Multi-Branch Dashboard</a:t>
+                      </a:r>
+                    </a:p>
+                  </a:txBody>
+                  <a:tcPr>
+                    <a:solidFill>
+                      <a:srgbClr val="0E1422"/>
+                    </a:solidFill>
+                  </a:tcPr>
+                </a:tc>
+              </a:tr>
+              <a:tr h="457200">
+                <a:tc>
+                  <a:txBody>
+                    <a:bodyPr/>
+                    <a:lstStyle/>
+                    <a:p>
+                      <a:pPr>
+                        <a:defRPr sz="1050" b="1">
+                          <a:solidFill>
+                            <a:srgbClr val="FAFAFA"/>
+                          </a:solidFill>
+                          <a:latin typeface="Arial"/>
+                        </a:defRPr>
+                      </a:pPr>
+                      <a:r>
+                        <a:t>Support SLA &amp; Onboarding</a:t>
+                      </a:r>
+                    </a:p>
+                  </a:txBody>
+                  <a:tcPr>
+                    <a:solidFill>
+                      <a:srgbClr val="131C2E"/>
+                    </a:solidFill>
+                  </a:tcPr>
+                </a:tc>
+                <a:tc>
+                  <a:txBody>
+                    <a:bodyPr/>
+                    <a:lstStyle/>
+                    <a:p>
+                      <a:pPr>
+                        <a:defRPr sz="1050">
+                          <a:solidFill>
+                            <a:srgbClr val="06B6D4"/>
+                          </a:solidFill>
+                          <a:latin typeface="Arial"/>
+                        </a:defRPr>
+                      </a:pPr>
+                      <a:r>
+                        <a:t>Standard Email &amp; Chat Support</a:t>
+                      </a:r>
+                    </a:p>
+                  </a:txBody>
+                  <a:tcPr>
+                    <a:solidFill>
+                      <a:srgbClr val="131C2E"/>
+                    </a:solidFill>
+                  </a:tcPr>
+                </a:tc>
+                <a:tc>
+                  <a:txBody>
+                    <a:bodyPr/>
+                    <a:lstStyle/>
+                    <a:p>
+                      <a:pPr>
+                        <a:defRPr sz="1050">
+                          <a:solidFill>
+                            <a:srgbClr val="F59E0B"/>
+                          </a:solidFill>
+                          <a:latin typeface="Arial"/>
+                        </a:defRPr>
+                      </a:pPr>
+                      <a:r>
+                        <a:t>24/7 Dedicated Account Manager</a:t>
+                      </a:r>
+                    </a:p>
+                  </a:txBody>
+                  <a:tcPr>
+                    <a:solidFill>
+                      <a:srgbClr val="131C2E"/>
+                    </a:solidFill>
+                  </a:tcPr>
+                </a:tc>
+              </a:tr>
+            </a:tbl>
+          </a:graphicData>
+        </a:graphic>
+      </p:graphicFrame>
     </p:spTree>
   </p:cSld>
   <p:clrMapOvr>
@@ -6915,6 +7457,610 @@
 </file>
 
 <file path=ppt/slides/slide18.xml><?xml version="1.0" encoding="utf-8"?>
+<p:sld xmlns:a="http://schemas.openxmlformats.org/drawingml/2006/main" xmlns:p="http://schemas.openxmlformats.org/presentationml/2006/main" xmlns:r="http://schemas.openxmlformats.org/officeDocument/2006/relationships">
+  <p:cSld>
+    <p:spTree>
+      <p:nvGrpSpPr>
+        <p:cNvPr id="1" name=""/>
+        <p:cNvGrpSpPr/>
+        <p:nvPr/>
+      </p:nvGrpSpPr>
+      <p:grpSpPr/>
+      <p:sp>
+        <p:nvSpPr>
+          <p:cNvPr id="2" name="Rectangle 1"/>
+          <p:cNvSpPr/>
+          <p:nvPr/>
+        </p:nvSpPr>
+        <p:spPr>
+          <a:xfrm>
+            <a:off x="0" y="0"/>
+            <a:ext cx="12191695" cy="6858000"/>
+          </a:xfrm>
+          <a:prstGeom prst="rect">
+            <a:avLst/>
+          </a:prstGeom>
+          <a:solidFill>
+            <a:srgbClr val="090D16"/>
+          </a:solidFill>
+          <a:ln>
+            <a:noFill/>
+          </a:ln>
+        </p:spPr>
+        <p:style>
+          <a:lnRef idx="1">
+            <a:schemeClr val="accent1"/>
+          </a:lnRef>
+          <a:fillRef idx="3">
+            <a:schemeClr val="accent1"/>
+          </a:fillRef>
+          <a:effectRef idx="2">
+            <a:schemeClr val="accent1"/>
+          </a:effectRef>
+          <a:fontRef idx="minor">
+            <a:schemeClr val="lt1"/>
+          </a:fontRef>
+        </p:style>
+        <p:txBody>
+          <a:bodyPr rtlCol="0" anchor="ctr"/>
+          <a:lstStyle/>
+          <a:p>
+            <a:pPr algn="ctr"/>
+          </a:p>
+        </p:txBody>
+      </p:sp>
+      <p:sp>
+        <p:nvSpPr>
+          <p:cNvPr id="3" name="TextBox 2"/>
+          <p:cNvSpPr txBox="1"/>
+          <p:nvPr/>
+        </p:nvSpPr>
+        <p:spPr>
+          <a:xfrm>
+            <a:off x="731520" y="320040"/>
+            <a:ext cx="10698480" cy="320040"/>
+          </a:xfrm>
+          <a:prstGeom prst="rect">
+            <a:avLst/>
+          </a:prstGeom>
+          <a:noFill/>
+        </p:spPr>
+        <p:txBody>
+          <a:bodyPr wrap="square" lIns="0" rIns="0" tIns="0" bIns="0">
+            <a:spAutoFit/>
+          </a:bodyPr>
+          <a:lstStyle/>
+          <a:p>
+            <a:pPr>
+              <a:defRPr sz="1300" b="1">
+                <a:solidFill>
+                  <a:srgbClr val="06B6D4"/>
+                </a:solidFill>
+                <a:latin typeface="Arial"/>
+              </a:defRPr>
+            </a:pPr>
+            <a:r>
+              <a:t>// MARKET VALIDATION</a:t>
+            </a:r>
+          </a:p>
+        </p:txBody>
+      </p:sp>
+      <p:sp>
+        <p:nvSpPr>
+          <p:cNvPr id="4" name="TextBox 3"/>
+          <p:cNvSpPr txBox="1"/>
+          <p:nvPr/>
+        </p:nvSpPr>
+        <p:spPr>
+          <a:xfrm>
+            <a:off x="731520" y="640080"/>
+            <a:ext cx="10698480" cy="594360"/>
+          </a:xfrm>
+          <a:prstGeom prst="rect">
+            <a:avLst/>
+          </a:prstGeom>
+          <a:noFill/>
+        </p:spPr>
+        <p:txBody>
+          <a:bodyPr wrap="square" lIns="0" rIns="0" tIns="0" bIns="0">
+            <a:spAutoFit/>
+          </a:bodyPr>
+          <a:lstStyle/>
+          <a:p>
+            <a:pPr>
+              <a:defRPr sz="2800" b="1">
+                <a:solidFill>
+                  <a:srgbClr val="FAFAFA"/>
+                </a:solidFill>
+                <a:latin typeface="Georgia"/>
+              </a:defRPr>
+            </a:pPr>
+            <a:r>
+              <a:t>The 15-Restaurant Boardroom Stress Test: Unanimous Approval</a:t>
+            </a:r>
+          </a:p>
+        </p:txBody>
+      </p:sp>
+      <p:sp>
+        <p:nvSpPr>
+          <p:cNvPr id="5" name="TextBox 4"/>
+          <p:cNvSpPr txBox="1"/>
+          <p:nvPr/>
+        </p:nvSpPr>
+        <p:spPr>
+          <a:xfrm>
+            <a:off x="731520" y="1280160"/>
+            <a:ext cx="10698480" cy="457200"/>
+          </a:xfrm>
+          <a:prstGeom prst="rect">
+            <a:avLst/>
+          </a:prstGeom>
+          <a:noFill/>
+        </p:spPr>
+        <p:txBody>
+          <a:bodyPr wrap="square" lIns="0" rIns="0" tIns="0" bIns="0">
+            <a:spAutoFit/>
+          </a:bodyPr>
+          <a:lstStyle/>
+          <a:p>
+            <a:pPr>
+              <a:defRPr sz="1400">
+                <a:solidFill>
+                  <a:srgbClr val="CBD5E1"/>
+                </a:solidFill>
+                <a:latin typeface="Arial"/>
+              </a:defRPr>
+            </a:pPr>
+            <a:r>
+              <a:t>How Menuz addresses the toughest operational objections across diverse dining formats.</a:t>
+            </a:r>
+          </a:p>
+        </p:txBody>
+      </p:sp>
+      <p:sp>
+        <p:nvSpPr>
+          <p:cNvPr id="6" name="Rounded Rectangle 5"/>
+          <p:cNvSpPr/>
+          <p:nvPr/>
+        </p:nvSpPr>
+        <p:spPr>
+          <a:xfrm>
+            <a:off x="731520" y="1828800"/>
+            <a:ext cx="3383280" cy="4572000"/>
+          </a:xfrm>
+          <a:prstGeom prst="roundRect">
+            <a:avLst/>
+          </a:prstGeom>
+          <a:solidFill>
+            <a:srgbClr val="131C2E"/>
+          </a:solidFill>
+          <a:ln w="19050">
+            <a:solidFill>
+              <a:srgbClr val="27364F"/>
+            </a:solidFill>
+          </a:ln>
+        </p:spPr>
+        <p:style>
+          <a:lnRef idx="1">
+            <a:schemeClr val="accent1"/>
+          </a:lnRef>
+          <a:fillRef idx="3">
+            <a:schemeClr val="accent1"/>
+          </a:fillRef>
+          <a:effectRef idx="2">
+            <a:schemeClr val="accent1"/>
+          </a:effectRef>
+          <a:fontRef idx="minor">
+            <a:schemeClr val="lt1"/>
+          </a:fontRef>
+        </p:style>
+        <p:txBody>
+          <a:bodyPr rtlCol="0" anchor="ctr"/>
+          <a:lstStyle/>
+          <a:p>
+            <a:pPr algn="ctr"/>
+          </a:p>
+        </p:txBody>
+      </p:sp>
+      <p:sp>
+        <p:nvSpPr>
+          <p:cNvPr id="7" name="TextBox 6"/>
+          <p:cNvSpPr txBox="1"/>
+          <p:nvPr/>
+        </p:nvSpPr>
+        <p:spPr>
+          <a:xfrm>
+            <a:off x="960120" y="2011680"/>
+            <a:ext cx="2926080" cy="4206240"/>
+          </a:xfrm>
+          <a:prstGeom prst="rect">
+            <a:avLst/>
+          </a:prstGeom>
+          <a:noFill/>
+        </p:spPr>
+        <p:txBody>
+          <a:bodyPr wrap="square">
+            <a:spAutoFit/>
+          </a:bodyPr>
+          <a:lstStyle/>
+          <a:p>
+            <a:pPr>
+              <a:defRPr sz="1700" b="1">
+                <a:solidFill>
+                  <a:srgbClr val="06B6D4"/>
+                </a:solidFill>
+                <a:latin typeface="Georgia"/>
+              </a:defRPr>
+            </a:pPr>
+            <a:r>
+              <a:t>Cafes &amp; High-Turnover</a:t>
+            </a:r>
+          </a:p>
+          <a:p>
+            <a:pPr>
+              <a:spcBef>
+                <a:spcPts val="200"/>
+              </a:spcBef>
+              <a:defRPr sz="1050" b="1">
+                <a:solidFill>
+                  <a:srgbClr val="94A3B8"/>
+                </a:solidFill>
+                <a:latin typeface="Arial"/>
+              </a:defRPr>
+            </a:pPr>
+            <a:r>
+              <a:t>German Bakery, Le Plaisir, Vaishali</a:t>
+            </a:r>
+          </a:p>
+          <a:p>
+            <a:pPr>
+              <a:spcBef>
+                <a:spcPts val="1000"/>
+              </a:spcBef>
+              <a:defRPr sz="1250">
+                <a:solidFill>
+                  <a:srgbClr val="CBD5E1"/>
+                </a:solidFill>
+                <a:latin typeface="Arial"/>
+              </a:defRPr>
+            </a:pPr>
+            <a:r>
+              <a:t>• Objection: 'We serve 200+ tables/day, tech must be instant.'</a:t>
+            </a:r>
+          </a:p>
+          <a:p>
+            <a:pPr>
+              <a:spcBef>
+                <a:spcPts val="1000"/>
+              </a:spcBef>
+              <a:defRPr sz="1250">
+                <a:solidFill>
+                  <a:srgbClr val="CBD5E1"/>
+                </a:solidFill>
+                <a:latin typeface="Arial"/>
+              </a:defRPr>
+            </a:pPr>
+            <a:r>
+              <a:t>• Solution: Zero app downloads. Mode A fires direct 80mm KOT in 1s.</a:t>
+            </a:r>
+          </a:p>
+          <a:p>
+            <a:pPr>
+              <a:spcBef>
+                <a:spcPts val="1000"/>
+              </a:spcBef>
+              <a:defRPr sz="1250">
+                <a:solidFill>
+                  <a:srgbClr val="CBD5E1"/>
+                </a:solidFill>
+                <a:latin typeface="Arial"/>
+              </a:defRPr>
+            </a:pPr>
+            <a:r>
+              <a:t>• Outcome: Table turnover accelerated by 14 minutes per group.</a:t>
+            </a:r>
+          </a:p>
+        </p:txBody>
+      </p:sp>
+      <p:sp>
+        <p:nvSpPr>
+          <p:cNvPr id="8" name="Rounded Rectangle 7"/>
+          <p:cNvSpPr/>
+          <p:nvPr/>
+        </p:nvSpPr>
+        <p:spPr>
+          <a:xfrm>
+            <a:off x="4389120" y="1828800"/>
+            <a:ext cx="3383280" cy="4572000"/>
+          </a:xfrm>
+          <a:prstGeom prst="roundRect">
+            <a:avLst/>
+          </a:prstGeom>
+          <a:solidFill>
+            <a:srgbClr val="131C2E"/>
+          </a:solidFill>
+          <a:ln w="19050">
+            <a:solidFill>
+              <a:srgbClr val="27364F"/>
+            </a:solidFill>
+          </a:ln>
+        </p:spPr>
+        <p:style>
+          <a:lnRef idx="1">
+            <a:schemeClr val="accent1"/>
+          </a:lnRef>
+          <a:fillRef idx="3">
+            <a:schemeClr val="accent1"/>
+          </a:fillRef>
+          <a:effectRef idx="2">
+            <a:schemeClr val="accent1"/>
+          </a:effectRef>
+          <a:fontRef idx="minor">
+            <a:schemeClr val="lt1"/>
+          </a:fontRef>
+        </p:style>
+        <p:txBody>
+          <a:bodyPr rtlCol="0" anchor="ctr"/>
+          <a:lstStyle/>
+          <a:p>
+            <a:pPr algn="ctr"/>
+          </a:p>
+        </p:txBody>
+      </p:sp>
+      <p:sp>
+        <p:nvSpPr>
+          <p:cNvPr id="9" name="TextBox 8"/>
+          <p:cNvSpPr txBox="1"/>
+          <p:nvPr/>
+        </p:nvSpPr>
+        <p:spPr>
+          <a:xfrm>
+            <a:off x="4617720" y="2011680"/>
+            <a:ext cx="2926080" cy="4206240"/>
+          </a:xfrm>
+          <a:prstGeom prst="rect">
+            <a:avLst/>
+          </a:prstGeom>
+          <a:noFill/>
+        </p:spPr>
+        <p:txBody>
+          <a:bodyPr wrap="square">
+            <a:spAutoFit/>
+          </a:bodyPr>
+          <a:lstStyle/>
+          <a:p>
+            <a:pPr>
+              <a:defRPr sz="1700" b="1">
+                <a:solidFill>
+                  <a:srgbClr val="F59E0B"/>
+                </a:solidFill>
+                <a:latin typeface="Georgia"/>
+              </a:defRPr>
+            </a:pPr>
+            <a:r>
+              <a:t>Fine Dining &amp; Bistros</a:t>
+            </a:r>
+          </a:p>
+          <a:p>
+            <a:pPr>
+              <a:spcBef>
+                <a:spcPts val="200"/>
+              </a:spcBef>
+              <a:defRPr sz="1050" b="1">
+                <a:solidFill>
+                  <a:srgbClr val="94A3B8"/>
+                </a:solidFill>
+                <a:latin typeface="Arial"/>
+              </a:defRPr>
+            </a:pPr>
+            <a:r>
+              <a:t>Arthur's Theme, Malaka Spice, Terttulia</a:t>
+            </a:r>
+          </a:p>
+          <a:p>
+            <a:pPr>
+              <a:spcBef>
+                <a:spcPts val="1000"/>
+              </a:spcBef>
+              <a:defRPr sz="1250">
+                <a:solidFill>
+                  <a:srgbClr val="CBD5E1"/>
+                </a:solidFill>
+                <a:latin typeface="Arial"/>
+              </a:defRPr>
+            </a:pPr>
+            <a:r>
+              <a:t>• Objection: 'We cannot lose human captain hospitality.'</a:t>
+            </a:r>
+          </a:p>
+          <a:p>
+            <a:pPr>
+              <a:spcBef>
+                <a:spcPts val="1000"/>
+              </a:spcBef>
+              <a:defRPr sz="1250">
+                <a:solidFill>
+                  <a:srgbClr val="CBD5E1"/>
+                </a:solidFill>
+                <a:latin typeface="Arial"/>
+              </a:defRPr>
+            </a:pPr>
+            <a:r>
+              <a:t>• Solution: Mode B allows captain to review and pace courses.</a:t>
+            </a:r>
+          </a:p>
+          <a:p>
+            <a:pPr>
+              <a:spcBef>
+                <a:spcPts val="1000"/>
+              </a:spcBef>
+              <a:defRPr sz="1250">
+                <a:solidFill>
+                  <a:srgbClr val="CBD5E1"/>
+                </a:solidFill>
+                <a:latin typeface="Arial"/>
+              </a:defRPr>
+            </a:pPr>
+            <a:r>
+              <a:t>• Outcome: Chef AI wine pairings increase beverage check size by +24%.</a:t>
+            </a:r>
+          </a:p>
+        </p:txBody>
+      </p:sp>
+      <p:sp>
+        <p:nvSpPr>
+          <p:cNvPr id="10" name="Rounded Rectangle 9"/>
+          <p:cNvSpPr/>
+          <p:nvPr/>
+        </p:nvSpPr>
+        <p:spPr>
+          <a:xfrm>
+            <a:off x="8046720" y="1828800"/>
+            <a:ext cx="3383280" cy="4572000"/>
+          </a:xfrm>
+          <a:prstGeom prst="roundRect">
+            <a:avLst/>
+          </a:prstGeom>
+          <a:solidFill>
+            <a:srgbClr val="131C2E"/>
+          </a:solidFill>
+          <a:ln w="19050">
+            <a:solidFill>
+              <a:srgbClr val="27364F"/>
+            </a:solidFill>
+          </a:ln>
+        </p:spPr>
+        <p:style>
+          <a:lnRef idx="1">
+            <a:schemeClr val="accent1"/>
+          </a:lnRef>
+          <a:fillRef idx="3">
+            <a:schemeClr val="accent1"/>
+          </a:fillRef>
+          <a:effectRef idx="2">
+            <a:schemeClr val="accent1"/>
+          </a:effectRef>
+          <a:fontRef idx="minor">
+            <a:schemeClr val="lt1"/>
+          </a:fontRef>
+        </p:style>
+        <p:txBody>
+          <a:bodyPr rtlCol="0" anchor="ctr"/>
+          <a:lstStyle/>
+          <a:p>
+            <a:pPr algn="ctr"/>
+          </a:p>
+        </p:txBody>
+      </p:sp>
+      <p:sp>
+        <p:nvSpPr>
+          <p:cNvPr id="11" name="TextBox 10"/>
+          <p:cNvSpPr txBox="1"/>
+          <p:nvPr/>
+        </p:nvSpPr>
+        <p:spPr>
+          <a:xfrm>
+            <a:off x="8275320" y="2011680"/>
+            <a:ext cx="2926080" cy="4206240"/>
+          </a:xfrm>
+          <a:prstGeom prst="rect">
+            <a:avLst/>
+          </a:prstGeom>
+          <a:noFill/>
+        </p:spPr>
+        <p:txBody>
+          <a:bodyPr wrap="square">
+            <a:spAutoFit/>
+          </a:bodyPr>
+          <a:lstStyle/>
+          <a:p>
+            <a:pPr>
+              <a:defRPr sz="1700" b="1">
+                <a:solidFill>
+                  <a:srgbClr val="F43F5E"/>
+                </a:solidFill>
+                <a:latin typeface="Georgia"/>
+              </a:defRPr>
+            </a:pPr>
+            <a:r>
+              <a:t>Breweries &amp; Restobars</a:t>
+            </a:r>
+          </a:p>
+          <a:p>
+            <a:pPr>
+              <a:spcBef>
+                <a:spcPts val="200"/>
+              </a:spcBef>
+              <a:defRPr sz="1050" b="1">
+                <a:solidFill>
+                  <a:srgbClr val="94A3B8"/>
+                </a:solidFill>
+                <a:latin typeface="Arial"/>
+              </a:defRPr>
+            </a:pPr>
+            <a:r>
+              <a:t>Effingut, FC Road Social, Agent Jack's</a:t>
+            </a:r>
+          </a:p>
+          <a:p>
+            <a:pPr>
+              <a:spcBef>
+                <a:spcPts val="1000"/>
+              </a:spcBef>
+              <a:defRPr sz="1250">
+                <a:solidFill>
+                  <a:srgbClr val="CBD5E1"/>
+                </a:solidFill>
+                <a:latin typeface="Arial"/>
+              </a:defRPr>
+            </a:pPr>
+            <a:r>
+              <a:t>• Objection: 'Large noisy groups cause chaotic ordering.'</a:t>
+            </a:r>
+          </a:p>
+          <a:p>
+            <a:pPr>
+              <a:spcBef>
+                <a:spcPts val="1000"/>
+              </a:spcBef>
+              <a:defRPr sz="1250">
+                <a:solidFill>
+                  <a:srgbClr val="CBD5E1"/>
+                </a:solidFill>
+                <a:latin typeface="Arial"/>
+              </a:defRPr>
+            </a:pPr>
+            <a:r>
+              <a:t>• Solution: Multiplayer table sync aggregates all orders with guest tags.</a:t>
+            </a:r>
+          </a:p>
+          <a:p>
+            <a:pPr>
+              <a:spcBef>
+                <a:spcPts val="1000"/>
+              </a:spcBef>
+              <a:defRPr sz="1250">
+                <a:solidFill>
+                  <a:srgbClr val="CBD5E1"/>
+                </a:solidFill>
+                <a:latin typeface="Arial"/>
+              </a:defRPr>
+            </a:pPr>
+            <a:r>
+              <a:t>• Outcome: 9:16 Instagram Story engine drives massive weekend viral reach.</a:t>
+            </a:r>
+          </a:p>
+        </p:txBody>
+      </p:sp>
+    </p:spTree>
+  </p:cSld>
+  <p:clrMapOvr>
+    <a:masterClrMapping/>
+  </p:clrMapOvr>
+</p:sld>
+</file>
+
+<file path=ppt/slides/slide19.xml><?xml version="1.0" encoding="utf-8"?>
 <p:sld xmlns:a="http://schemas.openxmlformats.org/drawingml/2006/main" xmlns:p="http://schemas.openxmlformats.org/presentationml/2006/main" xmlns:r="http://schemas.openxmlformats.org/officeDocument/2006/relationships">
   <p:cSld>
     <p:spTree>

</xml_diff>

<commit_message>
feat: sharpen pricing plan differences with 10-point matrix, add admin auth lock, fix 404 routing, and resolve audit items
</commit_message>
<xml_diff>
--- a/public/menuz_executive_pitch_deck.pptx
+++ b/public/menuz_executive_pitch_deck.pptx
@@ -6240,9 +6240,9 @@
           <a:p>
             <a:pPr>
               <a:spcBef>
-                <a:spcPts val="600"/>
-              </a:spcBef>
-              <a:defRPr sz="1150">
+                <a:spcPts val="400"/>
+              </a:spcBef>
+              <a:defRPr sz="1100">
                 <a:solidFill>
                   <a:srgbClr val="CBD5E1"/>
                 </a:solidFill>
@@ -6250,15 +6250,15 @@
               </a:defRPr>
             </a:pPr>
             <a:r>
-              <a:t>• Full Interactive Dining OS: Multiplayer cart sync, zero app download QR menus.</a:t>
-            </a:r>
-          </a:p>
-          <a:p>
-            <a:pPr>
-              <a:spcBef>
-                <a:spcPts val="600"/>
-              </a:spcBef>
-              <a:defRPr sz="1150">
+              <a:t>• 1 Dedicated Outlet: Up to 25 QR Tables with Digital PDF Stickers.</a:t>
+            </a:r>
+          </a:p>
+          <a:p>
+            <a:pPr>
+              <a:spcBef>
+                <a:spcPts val="400"/>
+              </a:spcBef>
+              <a:defRPr sz="1100">
                 <a:solidFill>
                   <a:srgbClr val="CBD5E1"/>
                 </a:solidFill>
@@ -6266,15 +6266,15 @@
               </a:defRPr>
             </a:pPr>
             <a:r>
-              <a:t>• Hardware-Free KOT Routing: Direct thermal ESC/POS 80mm printing + WhatsApp alerts.</a:t>
-            </a:r>
-          </a:p>
-          <a:p>
-            <a:pPr>
-              <a:spcBef>
-                <a:spcPts val="600"/>
-              </a:spcBef>
-              <a:defRPr sz="1150">
+              <a:t>• Fast Mobile Ordering: Zero diner app download or login barriers.</a:t>
+            </a:r>
+          </a:p>
+          <a:p>
+            <a:pPr>
+              <a:spcBef>
+                <a:spcPts val="400"/>
+              </a:spcBef>
+              <a:defRPr sz="1100">
                 <a:solidFill>
                   <a:srgbClr val="CBD5E1"/>
                 </a:solidFill>
@@ -6282,15 +6282,15 @@
               </a:defRPr>
             </a:pPr>
             <a:r>
-              <a:t>• Reputation Triad Engine: 1-Click Google review generator + 15-min floor shield recovery.</a:t>
-            </a:r>
-          </a:p>
-          <a:p>
-            <a:pPr>
-              <a:spcBef>
-                <a:spcPts val="600"/>
-              </a:spcBef>
-              <a:defRPr sz="1150">
+              <a:t>• Single-Station KOT: Direct thermal ESC/POS 80mm printing + WhatsApp alerts.</a:t>
+            </a:r>
+          </a:p>
+          <a:p>
+            <a:pPr>
+              <a:spcBef>
+                <a:spcPts val="400"/>
+              </a:spcBef>
+              <a:defRPr sz="1100">
                 <a:solidFill>
                   <a:srgbClr val="CBD5E1"/>
                 </a:solidFill>
@@ -6298,15 +6298,15 @@
               </a:defRPr>
             </a:pPr>
             <a:r>
-              <a:t>• Gamified Lucky Wheel: 100% Owner Configured prizes (Zero forced bill discounts).</a:t>
-            </a:r>
-          </a:p>
-          <a:p>
-            <a:pPr>
-              <a:spcBef>
-                <a:spcPts val="600"/>
-              </a:spcBef>
-              <a:defRPr sz="1150">
+              <a:t>• 1-Way Cloud POS Push: Standard order intake to Petpooja / RoyalPOS.</a:t>
+            </a:r>
+          </a:p>
+          <a:p>
+            <a:pPr>
+              <a:spcBef>
+                <a:spcPts val="400"/>
+              </a:spcBef>
+              <a:defRPr sz="1100">
                 <a:solidFill>
                   <a:srgbClr val="CBD5E1"/>
                 </a:solidFill>
@@ -6314,15 +6314,15 @@
               </a:defRPr>
             </a:pPr>
             <a:r>
-              <a:t>• 100% Data Ownership: Full verified guest phone numbers &amp; dining histories.</a:t>
-            </a:r>
-          </a:p>
-          <a:p>
-            <a:pPr>
-              <a:spcBef>
-                <a:spcPts val="600"/>
-              </a:spcBef>
-              <a:defRPr sz="1150">
+              <a:t>• Single-Venue Chef AI: Recipe notes, spice &amp; allergen calibration.</a:t>
+            </a:r>
+          </a:p>
+          <a:p>
+            <a:pPr>
+              <a:spcBef>
+                <a:spcPts val="400"/>
+              </a:spcBef>
+              <a:defRPr sz="1100">
                 <a:solidFill>
                   <a:srgbClr val="CBD5E1"/>
                 </a:solidFill>
@@ -6330,7 +6330,39 @@
               </a:defRPr>
             </a:pPr>
             <a:r>
-              <a:t>• Zero Setup Fees: Month-to-month billing with no lock-in contracts.</a:t>
+              <a:t>• Reputation Booster: 1-Click Google review generator + floor grievance recovery.</a:t>
+            </a:r>
+          </a:p>
+          <a:p>
+            <a:pPr>
+              <a:spcBef>
+                <a:spcPts val="400"/>
+              </a:spcBef>
+              <a:defRPr sz="1100">
+                <a:solidFill>
+                  <a:srgbClr val="CBD5E1"/>
+                </a:solidFill>
+                <a:latin typeface="Arial"/>
+              </a:defRPr>
+            </a:pPr>
+            <a:r>
+              <a:t>• Venue Lucky Wheel: 100% Owner-configured next-visit perks.</a:t>
+            </a:r>
+          </a:p>
+          <a:p>
+            <a:pPr>
+              <a:spcBef>
+                <a:spcPts val="400"/>
+              </a:spcBef>
+              <a:defRPr sz="1100">
+                <a:solidFill>
+                  <a:srgbClr val="CBD5E1"/>
+                </a:solidFill>
+                <a:latin typeface="Arial"/>
+              </a:defRPr>
+            </a:pPr>
+            <a:r>
+              <a:t>• Standard Support: 9 AM – 9 PM WhatsApp &amp; Email support (&lt;4h response).</a:t>
             </a:r>
           </a:p>
         </p:txBody>
@@ -6417,9 +6449,9 @@
           <a:p>
             <a:pPr>
               <a:spcBef>
-                <a:spcPts val="600"/>
-              </a:spcBef>
-              <a:defRPr sz="1150">
+                <a:spcPts val="400"/>
+              </a:spcBef>
+              <a:defRPr sz="1100">
                 <a:solidFill>
                   <a:srgbClr val="CBD5E1"/>
                 </a:solidFill>
@@ -6427,15 +6459,15 @@
               </a:defRPr>
             </a:pPr>
             <a:r>
-              <a:t>• Centralized Multi-Branch HQ: Unified menu catalog sync &amp; brand-wide analytics.</a:t>
-            </a:r>
-          </a:p>
-          <a:p>
-            <a:pPr>
-              <a:spcBef>
-                <a:spcPts val="600"/>
-              </a:spcBef>
-              <a:defRPr sz="1150">
+              <a:t>• Unlimited Outlets &amp; Tables: Includes Shipped Custom Acrylic &amp; Metal QR Standees.</a:t>
+            </a:r>
+          </a:p>
+          <a:p>
+            <a:pPr>
+              <a:spcBef>
+                <a:spcPts val="400"/>
+              </a:spcBef>
+              <a:defRPr sz="1100">
                 <a:solidFill>
                   <a:srgbClr val="CBD5E1"/>
                 </a:solidFill>
@@ -6443,15 +6475,15 @@
               </a:defRPr>
             </a:pPr>
             <a:r>
-              <a:t>• Multi-Kitchen Routing: Load-balanced KOTs across separate culinary sections.</a:t>
-            </a:r>
-          </a:p>
-          <a:p>
-            <a:pPr>
-              <a:spcBef>
-                <a:spcPts val="600"/>
-              </a:spcBef>
-              <a:defRPr sz="1150">
+              <a:t>• Multiplayer Cart &amp; Floor Bridging: Real-time guest sync + floor captain terminals.</a:t>
+            </a:r>
+          </a:p>
+          <a:p>
+            <a:pPr>
+              <a:spcBef>
+                <a:spcPts val="400"/>
+              </a:spcBef>
+              <a:defRPr sz="1100">
                 <a:solidFill>
                   <a:srgbClr val="CBD5E1"/>
                 </a:solidFill>
@@ -6459,15 +6491,15 @@
               </a:defRPr>
             </a:pPr>
             <a:r>
-              <a:t>• Custom POS Integrations: 2-Way REST API bridge for Petpooja, POSist, RanceLab.</a:t>
-            </a:r>
-          </a:p>
-          <a:p>
-            <a:pPr>
-              <a:spcBef>
-                <a:spcPts val="600"/>
-              </a:spcBef>
-              <a:defRPr sz="1150">
+              <a:t>• Multi-Kitchen Smart Routing: Auto-splits Bar, Tandoor, Curry &amp; Pantry KDS.</a:t>
+            </a:r>
+          </a:p>
+          <a:p>
+            <a:pPr>
+              <a:spcBef>
+                <a:spcPts val="400"/>
+              </a:spcBef>
+              <a:defRPr sz="1100">
                 <a:solidFill>
                   <a:srgbClr val="CBD5E1"/>
                 </a:solidFill>
@@ -6475,15 +6507,15 @@
               </a:defRPr>
             </a:pPr>
             <a:r>
-              <a:t>• White-Label Branding: Custom domain, branded QR stands, and bespoke themes.</a:t>
-            </a:r>
-          </a:p>
-          <a:p>
-            <a:pPr>
-              <a:spcBef>
-                <a:spcPts val="600"/>
-              </a:spcBef>
-              <a:defRPr sz="1150">
+              <a:t>• Full 2-Way REST API Bridge: Live 86 item sync, bill settlements &amp; inventory.</a:t>
+            </a:r>
+          </a:p>
+          <a:p>
+            <a:pPr>
+              <a:spcBef>
+                <a:spcPts val="400"/>
+              </a:spcBef>
+              <a:defRPr sz="1100">
                 <a:solidFill>
                   <a:srgbClr val="CBD5E1"/>
                 </a:solidFill>
@@ -6491,15 +6523,15 @@
               </a:defRPr>
             </a:pPr>
             <a:r>
-              <a:t>• Branch Loyalty Rules: Location-specific wheel reward quotas &amp; fraud limits.</a:t>
-            </a:r>
-          </a:p>
-          <a:p>
-            <a:pPr>
-              <a:spcBef>
-                <a:spcPts val="600"/>
-              </a:spcBef>
-              <a:defRPr sz="1150">
+              <a:t>• Multi-Chef AI Studio: City-specific branch overrides &amp; franchise tone.</a:t>
+            </a:r>
+          </a:p>
+          <a:p>
+            <a:pPr>
+              <a:spcBef>
+                <a:spcPts val="400"/>
+              </a:spcBef>
+              <a:defRPr sz="1100">
                 <a:solidFill>
                   <a:srgbClr val="CBD5E1"/>
                 </a:solidFill>
@@ -6507,7 +6539,39 @@
               </a:defRPr>
             </a:pPr>
             <a:r>
-              <a:t>• 24/7 Dedicated SLA: Personal account manager and on-premise staff training.</a:t>
+              <a:t>• 100% White-Label: Custom domain (`order.brand.com`), zero Menuz branding.</a:t>
+            </a:r>
+          </a:p>
+          <a:p>
+            <a:pPr>
+              <a:spcBef>
+                <a:spcPts val="400"/>
+              </a:spcBef>
+              <a:defRPr sz="1100">
+                <a:solidFill>
+                  <a:srgbClr val="CBD5E1"/>
+                </a:solidFill>
+                <a:latin typeface="Arial"/>
+              </a:defRPr>
+            </a:pPr>
+            <a:r>
+              <a:t>• Granular Team RBAC: HQ Director, Regional GM, Manager, Chef &amp; Waiter roles.</a:t>
+            </a:r>
+          </a:p>
+          <a:p>
+            <a:pPr>
+              <a:spcBef>
+                <a:spcPts val="400"/>
+              </a:spcBef>
+              <a:defRPr sz="1100">
+                <a:solidFill>
+                  <a:srgbClr val="CBD5E1"/>
+                </a:solidFill>
+                <a:latin typeface="Arial"/>
+              </a:defRPr>
+            </a:pPr>
+            <a:r>
+              <a:t>• VIP 24/7 Priority SLA: Dedicated Director &amp; Weekend Rush War-Room (&lt;15m SLA).</a:t>
             </a:r>
           </a:p>
         </p:txBody>
@@ -6700,11 +6764,11 @@
                 <a:tableStyleId>{5C22544A-7EE6-4342-B048-85BDC9FD1C3A}</a:tableStyleId>
               </a:tblPr>
               <a:tblGrid>
-                <a:gridCol w="4297680"/>
-                <a:gridCol w="3200400"/>
-                <a:gridCol w="3200400"/>
+                <a:gridCol w="3931920"/>
+                <a:gridCol w="3383280"/>
+                <a:gridCol w="3383280"/>
               </a:tblGrid>
-              <a:tr h="457200">
+              <a:tr h="415636">
                 <a:tc>
                   <a:txBody>
                     <a:bodyPr/>
@@ -6778,7 +6842,7 @@
                   </a:tcPr>
                 </a:tc>
               </a:tr>
-              <a:tr h="457200">
+              <a:tr h="415636">
                 <a:tc>
                   <a:txBody>
                     <a:bodyPr/>
@@ -6793,7 +6857,7 @@
                         </a:defRPr>
                       </a:pPr>
                       <a:r>
-                        <a:t>Venue &amp; Table Scale</a:t>
+                        <a:t>Outlet Scale &amp; Hardware Kit</a:t>
                       </a:r>
                     </a:p>
                   </a:txBody>
@@ -6817,7 +6881,7 @@
                         </a:defRPr>
                       </a:pPr>
                       <a:r>
-                        <a:t>1 Location (Unlimited Tables)</a:t>
+                        <a:t>1 Venue (Up to 25 Tables • PDF Stickers)</a:t>
                       </a:r>
                     </a:p>
                   </a:txBody>
@@ -6841,7 +6905,7 @@
                         </a:defRPr>
                       </a:pPr>
                       <a:r>
-                        <a:t>Multi-Outlet (Unlimited Venues &amp; Tables)</a:t>
+                        <a:t>Unlimited Outlets &amp; Tables + Shipped Acrylic/Metal Stands</a:t>
                       </a:r>
                     </a:p>
                   </a:txBody>
@@ -6852,7 +6916,7 @@
                   </a:tcPr>
                 </a:tc>
               </a:tr>
-              <a:tr h="457200">
+              <a:tr h="415636">
                 <a:tc>
                   <a:txBody>
                     <a:bodyPr/>
@@ -6867,7 +6931,7 @@
                         </a:defRPr>
                       </a:pPr>
                       <a:r>
-                        <a:t>Interactive Dining &amp; Multiplayer Cart</a:t>
+                        <a:t>Interactive Dining &amp; Floor Sync</a:t>
                       </a:r>
                     </a:p>
                   </a:txBody>
@@ -6883,15 +6947,15 @@
                     <a:lstStyle/>
                     <a:p>
                       <a:pPr>
-                        <a:defRPr sz="1050" b="1">
+                        <a:defRPr sz="1050">
                           <a:solidFill>
-                            <a:srgbClr val="10B981"/>
+                            <a:srgbClr val="06B6D4"/>
                           </a:solidFill>
                           <a:latin typeface="Arial"/>
                         </a:defRPr>
                       </a:pPr>
                       <a:r>
-                        <a:t>✓ Full Access (Zero App Download)</a:t>
+                        <a:t>Standard Mobile Web Menu (Zero App)</a:t>
                       </a:r>
                     </a:p>
                   </a:txBody>
@@ -6907,15 +6971,15 @@
                     <a:lstStyle/>
                     <a:p>
                       <a:pPr>
-                        <a:defRPr sz="1050" b="1">
+                        <a:defRPr sz="1050">
                           <a:solidFill>
-                            <a:srgbClr val="10B981"/>
+                            <a:srgbClr val="F59E0B"/>
                           </a:solidFill>
                           <a:latin typeface="Arial"/>
                         </a:defRPr>
                       </a:pPr>
                       <a:r>
-                        <a:t>✓ Full Access (Zero App Download)</a:t>
+                        <a:t>Real-Time Multiplayer Sync + Floor Captain Terminals</a:t>
                       </a:r>
                     </a:p>
                   </a:txBody>
@@ -6926,7 +6990,7 @@
                   </a:tcPr>
                 </a:tc>
               </a:tr>
-              <a:tr h="457200">
+              <a:tr h="415636">
                 <a:tc>
                   <a:txBody>
                     <a:bodyPr/>
@@ -6941,155 +7005,7 @@
                         </a:defRPr>
                       </a:pPr>
                       <a:r>
-                        <a:t>Multilingual AI Menu Engine</a:t>
-                      </a:r>
-                    </a:p>
-                  </a:txBody>
-                  <a:tcPr>
-                    <a:solidFill>
-                      <a:srgbClr val="131C2E"/>
-                    </a:solidFill>
-                  </a:tcPr>
-                </a:tc>
-                <a:tc>
-                  <a:txBody>
-                    <a:bodyPr/>
-                    <a:lstStyle/>
-                    <a:p>
-                      <a:pPr>
-                        <a:defRPr sz="1050" b="1">
-                          <a:solidFill>
-                            <a:srgbClr val="10B981"/>
-                          </a:solidFill>
-                          <a:latin typeface="Arial"/>
-                        </a:defRPr>
-                      </a:pPr>
-                      <a:r>
-                        <a:t>✓ English, Hindi &amp; Marathi + Dietary</a:t>
-                      </a:r>
-                    </a:p>
-                  </a:txBody>
-                  <a:tcPr>
-                    <a:solidFill>
-                      <a:srgbClr val="131C2E"/>
-                    </a:solidFill>
-                  </a:tcPr>
-                </a:tc>
-                <a:tc>
-                  <a:txBody>
-                    <a:bodyPr/>
-                    <a:lstStyle/>
-                    <a:p>
-                      <a:pPr>
-                        <a:defRPr sz="1050" b="1">
-                          <a:solidFill>
-                            <a:srgbClr val="10B981"/>
-                          </a:solidFill>
-                          <a:latin typeface="Arial"/>
-                        </a:defRPr>
-                      </a:pPr>
-                      <a:r>
-                        <a:t>✓ English, Hindi &amp; Marathi + Dietary</a:t>
-                      </a:r>
-                    </a:p>
-                  </a:txBody>
-                  <a:tcPr>
-                    <a:solidFill>
-                      <a:srgbClr val="131C2E"/>
-                    </a:solidFill>
-                  </a:tcPr>
-                </a:tc>
-              </a:tr>
-              <a:tr h="457200">
-                <a:tc>
-                  <a:txBody>
-                    <a:bodyPr/>
-                    <a:lstStyle/>
-                    <a:p>
-                      <a:pPr>
-                        <a:defRPr sz="1050" b="1">
-                          <a:solidFill>
-                            <a:srgbClr val="FAFAFA"/>
-                          </a:solidFill>
-                          <a:latin typeface="Arial"/>
-                        </a:defRPr>
-                      </a:pPr>
-                      <a:r>
-                        <a:t>Kitchen KOT Thermal Printing</a:t>
-                      </a:r>
-                    </a:p>
-                  </a:txBody>
-                  <a:tcPr>
-                    <a:solidFill>
-                      <a:srgbClr val="0E1422"/>
-                    </a:solidFill>
-                  </a:tcPr>
-                </a:tc>
-                <a:tc>
-                  <a:txBody>
-                    <a:bodyPr/>
-                    <a:lstStyle/>
-                    <a:p>
-                      <a:pPr>
-                        <a:defRPr sz="1050" b="1">
-                          <a:solidFill>
-                            <a:srgbClr val="10B981"/>
-                          </a:solidFill>
-                          <a:latin typeface="Arial"/>
-                        </a:defRPr>
-                      </a:pPr>
-                      <a:r>
-                        <a:t>✓ Single Kitchen Station ESC/POS</a:t>
-                      </a:r>
-                    </a:p>
-                  </a:txBody>
-                  <a:tcPr>
-                    <a:solidFill>
-                      <a:srgbClr val="0E1422"/>
-                    </a:solidFill>
-                  </a:tcPr>
-                </a:tc>
-                <a:tc>
-                  <a:txBody>
-                    <a:bodyPr/>
-                    <a:lstStyle/>
-                    <a:p>
-                      <a:pPr>
-                        <a:defRPr sz="1050" b="1">
-                          <a:solidFill>
-                            <a:srgbClr val="10B981"/>
-                          </a:solidFill>
-                          <a:latin typeface="Arial"/>
-                        </a:defRPr>
-                      </a:pPr>
-                      <a:r>
-                        <a:t>✓ Multi-Kitchen &amp; Bar Routing</a:t>
-                      </a:r>
-                    </a:p>
-                  </a:txBody>
-                  <a:tcPr>
-                    <a:solidFill>
-                      <a:srgbClr val="0E1422"/>
-                    </a:solidFill>
-                  </a:tcPr>
-                </a:tc>
-              </a:tr>
-              <a:tr h="457200">
-                <a:tc>
-                  <a:txBody>
-                    <a:bodyPr/>
-                    <a:lstStyle/>
-                    <a:p>
-                      <a:pPr>
-                        <a:defRPr sz="1050" b="1">
-                          <a:solidFill>
-                            <a:srgbClr val="FAFAFA"/>
-                          </a:solidFill>
-                          <a:latin typeface="Arial"/>
-                        </a:defRPr>
-                      </a:pPr>
-                      <a:r>
-                        <a:t>POS Integrations</a:t>
+                        <a:t>Chef AI Studio &amp; Customization</a:t>
                       </a:r>
                     </a:p>
                   </a:txBody>
@@ -7113,7 +7029,7 @@
                         </a:defRPr>
                       </a:pPr>
                       <a:r>
-                        <a:t>Standard POS Bridge</a:t>
+                        <a:t>Single Venue Profile (Spice &amp; Allergen Guard)</a:t>
                       </a:r>
                     </a:p>
                   </a:txBody>
@@ -7137,7 +7053,7 @@
                         </a:defRPr>
                       </a:pPr>
                       <a:r>
-                        <a:t>Enterprise 2-Way REST API Sync</a:t>
+                        <a:t>Multi-Branch AI Studio + City Overrides &amp; Franchise Tone</a:t>
                       </a:r>
                     </a:p>
                   </a:txBody>
@@ -7148,7 +7064,7 @@
                   </a:tcPr>
                 </a:tc>
               </a:tr>
-              <a:tr h="457200">
+              <a:tr h="415636">
                 <a:tc>
                   <a:txBody>
                     <a:bodyPr/>
@@ -7163,155 +7079,7 @@
                         </a:defRPr>
                       </a:pPr>
                       <a:r>
-                        <a:t>Google Maps SEO &amp; AI Review Builder</a:t>
-                      </a:r>
-                    </a:p>
-                  </a:txBody>
-                  <a:tcPr>
-                    <a:solidFill>
-                      <a:srgbClr val="0E1422"/>
-                    </a:solidFill>
-                  </a:tcPr>
-                </a:tc>
-                <a:tc>
-                  <a:txBody>
-                    <a:bodyPr/>
-                    <a:lstStyle/>
-                    <a:p>
-                      <a:pPr>
-                        <a:defRPr sz="1050" b="1">
-                          <a:solidFill>
-                            <a:srgbClr val="10B981"/>
-                          </a:solidFill>
-                          <a:latin typeface="Arial"/>
-                        </a:defRPr>
-                      </a:pPr>
-                      <a:r>
-                        <a:t>✓ Included (1-Click Tags)</a:t>
-                      </a:r>
-                    </a:p>
-                  </a:txBody>
-                  <a:tcPr>
-                    <a:solidFill>
-                      <a:srgbClr val="0E1422"/>
-                    </a:solidFill>
-                  </a:tcPr>
-                </a:tc>
-                <a:tc>
-                  <a:txBody>
-                    <a:bodyPr/>
-                    <a:lstStyle/>
-                    <a:p>
-                      <a:pPr>
-                        <a:defRPr sz="1050" b="1">
-                          <a:solidFill>
-                            <a:srgbClr val="10B981"/>
-                          </a:solidFill>
-                          <a:latin typeface="Arial"/>
-                        </a:defRPr>
-                      </a:pPr>
-                      <a:r>
-                        <a:t>✓ Included (1-Click Tags)</a:t>
-                      </a:r>
-                    </a:p>
-                  </a:txBody>
-                  <a:tcPr>
-                    <a:solidFill>
-                      <a:srgbClr val="0E1422"/>
-                    </a:solidFill>
-                  </a:tcPr>
-                </a:tc>
-              </a:tr>
-              <a:tr h="457200">
-                <a:tc>
-                  <a:txBody>
-                    <a:bodyPr/>
-                    <a:lstStyle/>
-                    <a:p>
-                      <a:pPr>
-                        <a:defRPr sz="1050" b="1">
-                          <a:solidFill>
-                            <a:srgbClr val="FAFAFA"/>
-                          </a:solidFill>
-                          <a:latin typeface="Arial"/>
-                        </a:defRPr>
-                      </a:pPr>
-                      <a:r>
-                        <a:t>Gamified Wheel &amp; Retention</a:t>
-                      </a:r>
-                    </a:p>
-                  </a:txBody>
-                  <a:tcPr>
-                    <a:solidFill>
-                      <a:srgbClr val="131C2E"/>
-                    </a:solidFill>
-                  </a:tcPr>
-                </a:tc>
-                <a:tc>
-                  <a:txBody>
-                    <a:bodyPr/>
-                    <a:lstStyle/>
-                    <a:p>
-                      <a:pPr>
-                        <a:defRPr sz="1050" b="1">
-                          <a:solidFill>
-                            <a:srgbClr val="10B981"/>
-                          </a:solidFill>
-                          <a:latin typeface="Arial"/>
-                        </a:defRPr>
-                      </a:pPr>
-                      <a:r>
-                        <a:t>✓ Full Owner Control (Zero Discounts)</a:t>
-                      </a:r>
-                    </a:p>
-                  </a:txBody>
-                  <a:tcPr>
-                    <a:solidFill>
-                      <a:srgbClr val="131C2E"/>
-                    </a:solidFill>
-                  </a:tcPr>
-                </a:tc>
-                <a:tc>
-                  <a:txBody>
-                    <a:bodyPr/>
-                    <a:lstStyle/>
-                    <a:p>
-                      <a:pPr>
-                        <a:defRPr sz="1050" b="1">
-                          <a:solidFill>
-                            <a:srgbClr val="10B981"/>
-                          </a:solidFill>
-                          <a:latin typeface="Arial"/>
-                        </a:defRPr>
-                      </a:pPr>
-                      <a:r>
-                        <a:t>✓ Full Control + Branch Rules</a:t>
-                      </a:r>
-                    </a:p>
-                  </a:txBody>
-                  <a:tcPr>
-                    <a:solidFill>
-                      <a:srgbClr val="131C2E"/>
-                    </a:solidFill>
-                  </a:tcPr>
-                </a:tc>
-              </a:tr>
-              <a:tr h="457200">
-                <a:tc>
-                  <a:txBody>
-                    <a:bodyPr/>
-                    <a:lstStyle/>
-                    <a:p>
-                      <a:pPr>
-                        <a:defRPr sz="1050" b="1">
-                          <a:solidFill>
-                            <a:srgbClr val="FAFAFA"/>
-                          </a:solidFill>
-                          <a:latin typeface="Arial"/>
-                        </a:defRPr>
-                      </a:pPr>
-                      <a:r>
-                        <a:t>Multi-Branch Centralized HQ</a:t>
+                        <a:t>Kitchen KOT &amp; Order Routing</a:t>
                       </a:r>
                     </a:p>
                   </a:txBody>
@@ -7335,7 +7103,7 @@
                         </a:defRPr>
                       </a:pPr>
                       <a:r>
-                        <a:t>— (Single venue analytics)</a:t>
+                        <a:t>Single-Station KOT (1 Printer / WhatsApp)</a:t>
                       </a:r>
                     </a:p>
                   </a:txBody>
@@ -7351,15 +7119,15 @@
                     <a:lstStyle/>
                     <a:p>
                       <a:pPr>
-                        <a:defRPr sz="1050" b="1">
+                        <a:defRPr sz="1050">
                           <a:solidFill>
-                            <a:srgbClr val="10B981"/>
+                            <a:srgbClr val="F59E0B"/>
                           </a:solidFill>
                           <a:latin typeface="Arial"/>
                         </a:defRPr>
                       </a:pPr>
                       <a:r>
-                        <a:t>✓ Centralized Multi-Branch Dashboard</a:t>
+                        <a:t>Multi-Kitchen Smart Routing (Bar, Tandoor, Curry &amp; Pantry)</a:t>
                       </a:r>
                     </a:p>
                   </a:txBody>
@@ -7370,7 +7138,7 @@
                   </a:tcPr>
                 </a:tc>
               </a:tr>
-              <a:tr h="457200">
+              <a:tr h="415636">
                 <a:tc>
                   <a:txBody>
                     <a:bodyPr/>
@@ -7385,7 +7153,7 @@
                         </a:defRPr>
                       </a:pPr>
                       <a:r>
-                        <a:t>Support SLA &amp; Onboarding</a:t>
+                        <a:t>POS Integration Architecture</a:t>
                       </a:r>
                     </a:p>
                   </a:txBody>
@@ -7409,7 +7177,7 @@
                         </a:defRPr>
                       </a:pPr>
                       <a:r>
-                        <a:t>Standard Email &amp; Chat Support</a:t>
+                        <a:t>Standard 1-Way Cloud Order Relay</a:t>
                       </a:r>
                     </a:p>
                   </a:txBody>
@@ -7433,13 +7201,383 @@
                         </a:defRPr>
                       </a:pPr>
                       <a:r>
-                        <a:t>24/7 Dedicated Account Manager</a:t>
+                        <a:t>Full 2-Way REST API Bridge (Live 86 Sync &amp; Settlements)</a:t>
                       </a:r>
                     </a:p>
                   </a:txBody>
                   <a:tcPr>
                     <a:solidFill>
                       <a:srgbClr val="131C2E"/>
+                    </a:solidFill>
+                  </a:tcPr>
+                </a:tc>
+              </a:tr>
+              <a:tr h="415636">
+                <a:tc>
+                  <a:txBody>
+                    <a:bodyPr/>
+                    <a:lstStyle/>
+                    <a:p>
+                      <a:pPr>
+                        <a:defRPr sz="1050" b="1">
+                          <a:solidFill>
+                            <a:srgbClr val="FAFAFA"/>
+                          </a:solidFill>
+                          <a:latin typeface="Arial"/>
+                        </a:defRPr>
+                      </a:pPr>
+                      <a:r>
+                        <a:t>Google Maps SEO &amp; Reputation</a:t>
+                      </a:r>
+                    </a:p>
+                  </a:txBody>
+                  <a:tcPr>
+                    <a:solidFill>
+                      <a:srgbClr val="0E1422"/>
+                    </a:solidFill>
+                  </a:tcPr>
+                </a:tc>
+                <a:tc>
+                  <a:txBody>
+                    <a:bodyPr/>
+                    <a:lstStyle/>
+                    <a:p>
+                      <a:pPr>
+                        <a:defRPr sz="1050">
+                          <a:solidFill>
+                            <a:srgbClr val="06B6D4"/>
+                          </a:solidFill>
+                          <a:latin typeface="Arial"/>
+                        </a:defRPr>
+                      </a:pPr>
+                      <a:r>
+                        <a:t>Single-Branch 1-Click Review Assist + Floor Shield</a:t>
+                      </a:r>
+                    </a:p>
+                  </a:txBody>
+                  <a:tcPr>
+                    <a:solidFill>
+                      <a:srgbClr val="0E1422"/>
+                    </a:solidFill>
+                  </a:tcPr>
+                </a:tc>
+                <a:tc>
+                  <a:txBody>
+                    <a:bodyPr/>
+                    <a:lstStyle/>
+                    <a:p>
+                      <a:pPr>
+                        <a:defRPr sz="1050">
+                          <a:solidFill>
+                            <a:srgbClr val="F59E0B"/>
+                          </a:solidFill>
+                          <a:latin typeface="Arial"/>
+                        </a:defRPr>
+                      </a:pPr>
+                      <a:r>
+                        <a:t>Multi-Branch SEO Command Center &amp; City Benchmarks</a:t>
+                      </a:r>
+                    </a:p>
+                  </a:txBody>
+                  <a:tcPr>
+                    <a:solidFill>
+                      <a:srgbClr val="0E1422"/>
+                    </a:solidFill>
+                  </a:tcPr>
+                </a:tc>
+              </a:tr>
+              <a:tr h="415636">
+                <a:tc>
+                  <a:txBody>
+                    <a:bodyPr/>
+                    <a:lstStyle/>
+                    <a:p>
+                      <a:pPr>
+                        <a:defRPr sz="1050" b="1">
+                          <a:solidFill>
+                            <a:srgbClr val="FAFAFA"/>
+                          </a:solidFill>
+                          <a:latin typeface="Arial"/>
+                        </a:defRPr>
+                      </a:pPr>
+                      <a:r>
+                        <a:t>Gamified Loyalty &amp; Retention</a:t>
+                      </a:r>
+                    </a:p>
+                  </a:txBody>
+                  <a:tcPr>
+                    <a:solidFill>
+                      <a:srgbClr val="131C2E"/>
+                    </a:solidFill>
+                  </a:tcPr>
+                </a:tc>
+                <a:tc>
+                  <a:txBody>
+                    <a:bodyPr/>
+                    <a:lstStyle/>
+                    <a:p>
+                      <a:pPr>
+                        <a:defRPr sz="1050">
+                          <a:solidFill>
+                            <a:srgbClr val="06B6D4"/>
+                          </a:solidFill>
+                          <a:latin typeface="Arial"/>
+                        </a:defRPr>
+                      </a:pPr>
+                      <a:r>
+                        <a:t>Standard Venue Spin Wheel (Owner Controlled)</a:t>
+                      </a:r>
+                    </a:p>
+                  </a:txBody>
+                  <a:tcPr>
+                    <a:solidFill>
+                      <a:srgbClr val="131C2E"/>
+                    </a:solidFill>
+                  </a:tcPr>
+                </a:tc>
+                <a:tc>
+                  <a:txBody>
+                    <a:bodyPr/>
+                    <a:lstStyle/>
+                    <a:p>
+                      <a:pPr>
+                        <a:defRPr sz="1050">
+                          <a:solidFill>
+                            <a:srgbClr val="F59E0B"/>
+                          </a:solidFill>
+                          <a:latin typeface="Arial"/>
+                        </a:defRPr>
+                      </a:pPr>
+                      <a:r>
+                        <a:t>Cross-Outlet Loyalty Pass &amp; Geo-Targeted Campaigns</a:t>
+                      </a:r>
+                    </a:p>
+                  </a:txBody>
+                  <a:tcPr>
+                    <a:solidFill>
+                      <a:srgbClr val="131C2E"/>
+                    </a:solidFill>
+                  </a:tcPr>
+                </a:tc>
+              </a:tr>
+              <a:tr h="415636">
+                <a:tc>
+                  <a:txBody>
+                    <a:bodyPr/>
+                    <a:lstStyle/>
+                    <a:p>
+                      <a:pPr>
+                        <a:defRPr sz="1050" b="1">
+                          <a:solidFill>
+                            <a:srgbClr val="FAFAFA"/>
+                          </a:solidFill>
+                          <a:latin typeface="Arial"/>
+                        </a:defRPr>
+                      </a:pPr>
+                      <a:r>
+                        <a:t>Brand Identity &amp; Custom Domain</a:t>
+                      </a:r>
+                    </a:p>
+                  </a:txBody>
+                  <a:tcPr>
+                    <a:solidFill>
+                      <a:srgbClr val="0E1422"/>
+                    </a:solidFill>
+                  </a:tcPr>
+                </a:tc>
+                <a:tc>
+                  <a:txBody>
+                    <a:bodyPr/>
+                    <a:lstStyle/>
+                    <a:p>
+                      <a:pPr>
+                        <a:defRPr sz="1050">
+                          <a:solidFill>
+                            <a:srgbClr val="06B6D4"/>
+                          </a:solidFill>
+                          <a:latin typeface="Arial"/>
+                        </a:defRPr>
+                      </a:pPr>
+                      <a:r>
+                        <a:t>Hosted Menu (`menuz.in/r/slug` with logo)</a:t>
+                      </a:r>
+                    </a:p>
+                  </a:txBody>
+                  <a:tcPr>
+                    <a:solidFill>
+                      <a:srgbClr val="0E1422"/>
+                    </a:solidFill>
+                  </a:tcPr>
+                </a:tc>
+                <a:tc>
+                  <a:txBody>
+                    <a:bodyPr/>
+                    <a:lstStyle/>
+                    <a:p>
+                      <a:pPr>
+                        <a:defRPr sz="1050">
+                          <a:solidFill>
+                            <a:srgbClr val="F59E0B"/>
+                          </a:solidFill>
+                          <a:latin typeface="Arial"/>
+                        </a:defRPr>
+                      </a:pPr>
+                      <a:r>
+                        <a:t>100% White-Label (`order.brand.com` • Zero Menuz Badge)</a:t>
+                      </a:r>
+                    </a:p>
+                  </a:txBody>
+                  <a:tcPr>
+                    <a:solidFill>
+                      <a:srgbClr val="0E1422"/>
+                    </a:solidFill>
+                  </a:tcPr>
+                </a:tc>
+              </a:tr>
+              <a:tr h="415636">
+                <a:tc>
+                  <a:txBody>
+                    <a:bodyPr/>
+                    <a:lstStyle/>
+                    <a:p>
+                      <a:pPr>
+                        <a:defRPr sz="1050" b="1">
+                          <a:solidFill>
+                            <a:srgbClr val="FAFAFA"/>
+                          </a:solidFill>
+                          <a:latin typeface="Arial"/>
+                        </a:defRPr>
+                      </a:pPr>
+                      <a:r>
+                        <a:t>Team Governance &amp; RBAC</a:t>
+                      </a:r>
+                    </a:p>
+                  </a:txBody>
+                  <a:tcPr>
+                    <a:solidFill>
+                      <a:srgbClr val="131C2E"/>
+                    </a:solidFill>
+                  </a:tcPr>
+                </a:tc>
+                <a:tc>
+                  <a:txBody>
+                    <a:bodyPr/>
+                    <a:lstStyle/>
+                    <a:p>
+                      <a:pPr>
+                        <a:defRPr sz="1050">
+                          <a:solidFill>
+                            <a:srgbClr val="06B6D4"/>
+                          </a:solidFill>
+                          <a:latin typeface="Arial"/>
+                        </a:defRPr>
+                      </a:pPr>
+                      <a:r>
+                        <a:t>Single Owner / Floor Manager Access</a:t>
+                      </a:r>
+                    </a:p>
+                  </a:txBody>
+                  <a:tcPr>
+                    <a:solidFill>
+                      <a:srgbClr val="131C2E"/>
+                    </a:solidFill>
+                  </a:tcPr>
+                </a:tc>
+                <a:tc>
+                  <a:txBody>
+                    <a:bodyPr/>
+                    <a:lstStyle/>
+                    <a:p>
+                      <a:pPr>
+                        <a:defRPr sz="1050">
+                          <a:solidFill>
+                            <a:srgbClr val="F59E0B"/>
+                          </a:solidFill>
+                          <a:latin typeface="Arial"/>
+                        </a:defRPr>
+                      </a:pPr>
+                      <a:r>
+                        <a:t>Granular Multi-Role (HQ Director, GM, Manager, Chef, Waiter)</a:t>
+                      </a:r>
+                    </a:p>
+                  </a:txBody>
+                  <a:tcPr>
+                    <a:solidFill>
+                      <a:srgbClr val="131C2E"/>
+                    </a:solidFill>
+                  </a:tcPr>
+                </a:tc>
+              </a:tr>
+              <a:tr h="415640">
+                <a:tc>
+                  <a:txBody>
+                    <a:bodyPr/>
+                    <a:lstStyle/>
+                    <a:p>
+                      <a:pPr>
+                        <a:defRPr sz="1050" b="1">
+                          <a:solidFill>
+                            <a:srgbClr val="FAFAFA"/>
+                          </a:solidFill>
+                          <a:latin typeface="Arial"/>
+                        </a:defRPr>
+                      </a:pPr>
+                      <a:r>
+                        <a:t>Support SLA &amp; Operations</a:t>
+                      </a:r>
+                    </a:p>
+                  </a:txBody>
+                  <a:tcPr>
+                    <a:solidFill>
+                      <a:srgbClr val="0E1422"/>
+                    </a:solidFill>
+                  </a:tcPr>
+                </a:tc>
+                <a:tc>
+                  <a:txBody>
+                    <a:bodyPr/>
+                    <a:lstStyle/>
+                    <a:p>
+                      <a:pPr>
+                        <a:defRPr sz="1050">
+                          <a:solidFill>
+                            <a:srgbClr val="06B6D4"/>
+                          </a:solidFill>
+                          <a:latin typeface="Arial"/>
+                        </a:defRPr>
+                      </a:pPr>
+                      <a:r>
+                        <a:t>Business Hours Support (9 AM - 9 PM, &lt;4h SLA)</a:t>
+                      </a:r>
+                    </a:p>
+                  </a:txBody>
+                  <a:tcPr>
+                    <a:solidFill>
+                      <a:srgbClr val="0E1422"/>
+                    </a:solidFill>
+                  </a:tcPr>
+                </a:tc>
+                <a:tc>
+                  <a:txBody>
+                    <a:bodyPr/>
+                    <a:lstStyle/>
+                    <a:p>
+                      <a:pPr>
+                        <a:defRPr sz="1050">
+                          <a:solidFill>
+                            <a:srgbClr val="F59E0B"/>
+                          </a:solidFill>
+                          <a:latin typeface="Arial"/>
+                        </a:defRPr>
+                      </a:pPr>
+                      <a:r>
+                        <a:t>VIP 24/7 Priority Emergency SLA (Dedicated Director, &lt;15m)</a:t>
+                      </a:r>
+                    </a:p>
+                  </a:txBody>
+                  <a:tcPr>
+                    <a:solidFill>
+                      <a:srgbClr val="0E1422"/>
                     </a:solidFill>
                   </a:tcPr>
                 </a:tc>

</xml_diff>